<commit_message>
Actualizar balance de julio con los EEFF de agosto corregidos
El estado de resultados corregido coincide con las cifras ya usadas;
solo cambia el balance de julio (activo corriente, pasivos y patrimonio),
que afecta las comparaciones y los indicadores frente a julio.

Co-Authored-By: Claude Opus 5.5 <noreply@anthropic.com>
Claude-Session: https://claude.ai/code/session_013o6dYMNGXV2KP4Cp5BSjoR
</commit_message>
<xml_diff>
--- a/presentaciones/juridica/Analisis_Financiero_Juridica_Agosto_2026.pptx
+++ b/presentaciones/juridica/Analisis_Financiero_Juridica_Agosto_2026.pptx
@@ -123,18 +123,18 @@
   <p:extLst>
     <p:ext uri="{521415D9-36F7-43E2-AB2F-B90AF26B5E84}">
       <p14:sectionLst xmlns:p14="http://schemas.microsoft.com/office/powerpoint/2010/main">
-        <p14:section name="Portada" id="{7d8985fb-19bb-607e-0695-99afdf21fedd}">
+        <p14:section name="Portada" id="{bec4d444-e675-d36b-27d7-1d8ee64fcd72}">
           <p14:sldIdLst>
             <p14:sldId id="256"/>
             <p14:sldId id="257"/>
           </p14:sldIdLst>
         </p14:section>
-        <p14:section name="1. Resumen ejecutivo" id="{6081e559-07f9-b629-dcc3-a65f0933351c}">
+        <p14:section name="1. Resumen ejecutivo" id="{07ee433d-af36-168b-cabd-13e2dbb24797}">
           <p14:sldIdLst>
             <p14:sldId id="258"/>
           </p14:sldIdLst>
         </p14:section>
-        <p14:section name="2. Estado de resultados" id="{ed4387f9-7739-8da7-02ad-23f161d25887}">
+        <p14:section name="2. Estado de resultados" id="{62c37de3-3898-983f-ad20-630019ac045f}">
           <p14:sldIdLst>
             <p14:sldId id="259"/>
             <p14:sldId id="260"/>
@@ -143,26 +143,26 @@
             <p14:sldId id="263"/>
           </p14:sldIdLst>
         </p14:section>
-        <p14:section name="3. Ingresos y gastos" id="{7fb528ec-e114-55da-ad03-282a9999e456}">
+        <p14:section name="3. Ingresos y gastos" id="{b3c4d1af-2130-73f2-48f2-ff14aba22bd6}">
           <p14:sldIdLst>
             <p14:sldId id="264"/>
             <p14:sldId id="265"/>
             <p14:sldId id="266"/>
           </p14:sldIdLst>
         </p14:section>
-        <p14:section name="4. Análisis de causas" id="{19877a6a-e486-4f66-6b19-a2b347245c8e}">
+        <p14:section name="4. Análisis de causas" id="{1e991dd0-d117-9f6c-096e-b09f00a464a0}">
           <p14:sldIdLst>
             <p14:sldId id="267"/>
           </p14:sldIdLst>
         </p14:section>
-        <p14:section name="5. Situación financiera" id="{af50c248-3ba0-f6b4-6379-25666bd83b6d}">
+        <p14:section name="5. Situación financiera" id="{46e91deb-1c01-d316-e402-a3a3f323dd69}">
           <p14:sldIdLst>
             <p14:sldId id="268"/>
             <p14:sldId id="269"/>
             <p14:sldId id="270"/>
           </p14:sldIdLst>
         </p14:section>
-        <p14:section name="6. Conclusiones" id="{81c12397-0e61-0d04-6218-be354e56e303}">
+        <p14:section name="6. Conclusiones" id="{833ac1c4-8592-7900-b1e6-2aeda0ec5810}">
           <p14:sldIdLst>
             <p14:sldId id="271"/>
             <p14:sldId id="272"/>
@@ -12224,7 +12224,7 @@
                             <a:srgbClr val="5A6572"/>
                           </a:solidFill>
                         </a:rPr>
-                        <a:t>1.040,5</a:t>
+                        <a:t>1.040,6</a:t>
                       </a:r>
                       <a:endParaRPr lang="en-US" sz="1200" dirty="0"/>
                     </a:p>
@@ -12285,7 +12285,7 @@
                             <a:schemeClr val="accent2"/>
                           </a:solidFill>
                         </a:rPr>
-                        <a:t>+34,5</a:t>
+                        <a:t>+34,4</a:t>
                       </a:r>
                       <a:endParaRPr lang="en-US" sz="1200" dirty="0"/>
                     </a:p>
@@ -12838,7 +12838,7 @@
                             <a:srgbClr val="5A6572"/>
                           </a:solidFill>
                         </a:rPr>
-                        <a:t>1.973,1</a:t>
+                        <a:t>1.973,2</a:t>
                       </a:r>
                       <a:endParaRPr lang="en-US" sz="1200" dirty="0"/>
                     </a:p>
@@ -12899,7 +12899,7 @@
                             <a:schemeClr val="accent2"/>
                           </a:solidFill>
                         </a:rPr>
-                        <a:t>+41,0</a:t>
+                        <a:t>+40,9</a:t>
                       </a:r>
                       <a:endParaRPr lang="en-US" sz="1200" dirty="0"/>
                     </a:p>
@@ -13220,7 +13220,7 @@
                             <a:srgbClr val="5A6572"/>
                           </a:solidFill>
                         </a:rPr>
-                        <a:t>154,1</a:t>
+                        <a:t>154,8</a:t>
                       </a:r>
                       <a:endParaRPr lang="en-US" sz="1200" dirty="0"/>
                     </a:p>
@@ -13281,7 +13281,7 @@
                             <a:schemeClr val="accent6"/>
                           </a:solidFill>
                         </a:rPr>
-                        <a:t>+34,8</a:t>
+                        <a:t>+34,0</a:t>
                       </a:r>
                       <a:endParaRPr lang="en-US" sz="1200" dirty="0"/>
                     </a:p>
@@ -13342,7 +13342,7 @@
                             <a:schemeClr val="accent6"/>
                           </a:solidFill>
                         </a:rPr>
-                        <a:t>+22,6%</a:t>
+                        <a:t>+22,0%</a:t>
                       </a:r>
                       <a:endParaRPr lang="en-US" sz="1200" dirty="0"/>
                     </a:p>
@@ -13527,7 +13527,7 @@
                             <a:srgbClr val="5A6572"/>
                           </a:solidFill>
                         </a:rPr>
-                        <a:t>6,3</a:t>
+                        <a:t>5,3</a:t>
                       </a:r>
                       <a:endParaRPr lang="en-US" sz="1200" dirty="0"/>
                     </a:p>
@@ -13585,10 +13585,10 @@
                       <a:r>
                         <a:rPr lang="en-US" sz="1200" b="1" dirty="0">
                           <a:solidFill>
-                            <a:schemeClr val="accent2"/>
+                            <a:schemeClr val="accent6"/>
                           </a:solidFill>
                         </a:rPr>
-                        <a:t>−0,3</a:t>
+                        <a:t>+0,7</a:t>
                       </a:r>
                       <a:endParaRPr lang="en-US" sz="1200" dirty="0"/>
                     </a:p>
@@ -13646,10 +13646,10 @@
                       <a:r>
                         <a:rPr lang="en-US" sz="1200" b="1" dirty="0">
                           <a:solidFill>
-                            <a:schemeClr val="accent2"/>
+                            <a:schemeClr val="accent6"/>
                           </a:solidFill>
                         </a:rPr>
-                        <a:t>−5,1%</a:t>
+                        <a:t>+13,6%</a:t>
                       </a:r>
                       <a:endParaRPr lang="en-US" sz="1200" dirty="0"/>
                     </a:p>
@@ -13834,7 +13834,7 @@
                             <a:srgbClr val="5A6572"/>
                           </a:solidFill>
                         </a:rPr>
-                        <a:t>160,4</a:t>
+                        <a:t>160,1</a:t>
                       </a:r>
                       <a:endParaRPr lang="en-US" sz="1200" dirty="0"/>
                     </a:p>
@@ -13895,7 +13895,7 @@
                             <a:schemeClr val="accent6"/>
                           </a:solidFill>
                         </a:rPr>
-                        <a:t>+34,5</a:t>
+                        <a:t>+34,7</a:t>
                       </a:r>
                       <a:endParaRPr lang="en-US" sz="1200" dirty="0"/>
                     </a:p>
@@ -13956,7 +13956,7 @@
                             <a:schemeClr val="accent6"/>
                           </a:solidFill>
                         </a:rPr>
-                        <a:t>+21,5%</a:t>
+                        <a:t>+21,7%</a:t>
                       </a:r>
                       <a:endParaRPr lang="en-US" sz="1200" dirty="0"/>
                     </a:p>
@@ -14216,7 +14216,7 @@
                             <a:srgbClr val="5A6572"/>
                           </a:solidFill>
                         </a:rPr>
-                        <a:t>1.812,7</a:t>
+                        <a:t>1.813,1</a:t>
                       </a:r>
                       <a:endParaRPr lang="en-US" sz="1200" dirty="0"/>
                     </a:p>
@@ -14277,7 +14277,7 @@
                             <a:schemeClr val="accent2"/>
                           </a:solidFill>
                         </a:rPr>
-                        <a:t>+6,5</a:t>
+                        <a:t>+6,2</a:t>
                       </a:r>
                       <a:endParaRPr lang="en-US" sz="1200" dirty="0"/>
                     </a:p>
@@ -14338,7 +14338,7 @@
                             <a:schemeClr val="accent2"/>
                           </a:solidFill>
                         </a:rPr>
-                        <a:t>+0,4%</a:t>
+                        <a:t>+0,3%</a:t>
                       </a:r>
                       <a:endParaRPr lang="en-US" sz="1200" dirty="0"/>
                     </a:p>
@@ -14523,7 +14523,7 @@
                             <a:srgbClr val="5A6572"/>
                           </a:solidFill>
                         </a:rPr>
-                        <a:t>1.973,1</a:t>
+                        <a:t>1.973,2</a:t>
                       </a:r>
                       <a:endParaRPr lang="en-US" sz="1200" dirty="0"/>
                     </a:p>
@@ -14584,7 +14584,7 @@
                             <a:schemeClr val="accent2"/>
                           </a:solidFill>
                         </a:rPr>
-                        <a:t>+41,0</a:t>
+                        <a:t>+40,9</a:t>
                       </a:r>
                       <a:endParaRPr lang="en-US" sz="1200" dirty="0"/>
                     </a:p>
@@ -14754,7 +14754,7 @@
                   <a:schemeClr val="tx1"/>
                 </a:solidFill>
               </a:rPr>
-              <a:t>El activo corriente creció $34,5 M, impulsado por bancos (+$43,9 M); el pasivo corriente subió $34,8 M por el anticipo del SIMPLE por pagar ($44,6 M).</a:t>
+              <a:t>El activo corriente creció $34,4 M, impulsado por bancos (+$43,9 M); el pasivo corriente subió $34,0 M por el anticipo del SIMPLE por pagar ($44,6 M).</a:t>
             </a:r>
             <a:endParaRPr lang="en-US" sz="1200" dirty="0"/>
           </a:p>
@@ -15516,7 +15516,7 @@
                             <a:srgbClr val="5A6572"/>
                           </a:solidFill>
                         </a:rPr>
-                        <a:t>6,75</a:t>
+                        <a:t>6,72</a:t>
                       </a:r>
                       <a:endParaRPr lang="en-US" sz="1200" dirty="0"/>
                     </a:p>
@@ -16986,7 +16986,7 @@
                   <a:schemeClr val="tx1"/>
                 </a:solidFill>
               </a:rPr>
-              <a:t>Por cada peso de pasivo corriente hay $5,69 de activo corriente (julio: 6,75).</a:t>
+              <a:t>Por cada peso de pasivo corriente hay $5,69 de activo corriente (julio: 6,72).</a:t>
             </a:r>
             <a:endParaRPr lang="en-US" sz="1200" dirty="0"/>
           </a:p>
@@ -17910,7 +17910,7 @@
                   <a:schemeClr val="tx1"/>
                 </a:solidFill>
               </a:rPr>
-              <a:t>razón corriente de 5,69 (vs 6,75) y endeudamiento de 9,7% (vs 8,1%), por el anticipo del SIMPLE por pagar ($44,6 M).</a:t>
+              <a:t>razón corriente de 5,69 (vs 6,72) y endeudamiento de 9,7% (vs 8,1%), por el anticipo del SIMPLE por pagar ($44,6 M).</a:t>
             </a:r>
             <a:endParaRPr lang="en-US" sz="1400" dirty="0"/>
           </a:p>
@@ -18015,7 +18015,7 @@
                   <a:schemeClr val="accent1"/>
                 </a:solidFill>
               </a:rPr>
-              <a:t>Patrimonio +0,4% y activo total +2,1%: </a:t>
+              <a:t>Patrimonio +0,3% y activo total +2,1%: </a:t>
             </a:r>
             <a:pPr indent="0" marL="0">
               <a:buNone/>
@@ -19727,7 +19727,7 @@
                   <a:srgbClr val="5A6572"/>
                 </a:solidFill>
               </a:rPr>
-              <a:t>Julio: $1.973,1 M</a:t>
+              <a:t>Julio: $1.973,2 M</a:t>
             </a:r>
             <a:endParaRPr lang="en-US" sz="1200" dirty="0"/>
           </a:p>
@@ -19898,7 +19898,7 @@
                   <a:srgbClr val="5A6572"/>
                 </a:solidFill>
               </a:rPr>
-              <a:t>Julio: $1.812,7 M</a:t>
+              <a:t>Julio: $1.813,1 M</a:t>
             </a:r>
             <a:endParaRPr lang="en-US" sz="1200" dirty="0"/>
           </a:p>
@@ -19934,7 +19934,7 @@
                   <a:schemeClr val="accent2"/>
                 </a:solidFill>
               </a:rPr>
-              <a:t>▲ +0,4% vs. julio</a:t>
+              <a:t>▲ +0,3% vs. julio</a:t>
             </a:r>
             <a:endParaRPr lang="en-US" sz="1200" dirty="0"/>
           </a:p>
@@ -23123,7 +23123,7 @@
                             <a:srgbClr val="5A6572"/>
                           </a:solidFill>
                         </a:rPr>
-                        <a:t>1.973,1</a:t>
+                        <a:t>1.973,2</a:t>
                       </a:r>
                       <a:endParaRPr lang="en-US" sz="1200" dirty="0"/>
                     </a:p>
@@ -23184,7 +23184,7 @@
                             <a:schemeClr val="accent2"/>
                           </a:solidFill>
                         </a:rPr>
-                        <a:t>+41,0</a:t>
+                        <a:t>+40,9</a:t>
                       </a:r>
                       <a:endParaRPr lang="en-US" sz="1200" dirty="0"/>
                     </a:p>
@@ -23430,7 +23430,7 @@
                             <a:srgbClr val="5A6572"/>
                           </a:solidFill>
                         </a:rPr>
-                        <a:t>160,4</a:t>
+                        <a:t>160,1</a:t>
                       </a:r>
                       <a:endParaRPr lang="en-US" sz="1200" dirty="0"/>
                     </a:p>
@@ -23491,7 +23491,7 @@
                             <a:schemeClr val="accent6"/>
                           </a:solidFill>
                         </a:rPr>
-                        <a:t>+34,5</a:t>
+                        <a:t>+34,7</a:t>
                       </a:r>
                       <a:endParaRPr lang="en-US" sz="1200" dirty="0"/>
                     </a:p>
@@ -23552,7 +23552,7 @@
                             <a:schemeClr val="accent6"/>
                           </a:solidFill>
                         </a:rPr>
-                        <a:t>+21,5%</a:t>
+                        <a:t>+21,7%</a:t>
                       </a:r>
                       <a:endParaRPr lang="en-US" sz="1200" dirty="0"/>
                     </a:p>
@@ -23737,7 +23737,7 @@
                             <a:srgbClr val="5A6572"/>
                           </a:solidFill>
                         </a:rPr>
-                        <a:t>1.812,7</a:t>
+                        <a:t>1.813,1</a:t>
                       </a:r>
                       <a:endParaRPr lang="en-US" sz="1200" dirty="0"/>
                     </a:p>
@@ -23798,7 +23798,7 @@
                             <a:schemeClr val="accent2"/>
                           </a:solidFill>
                         </a:rPr>
-                        <a:t>+6,5</a:t>
+                        <a:t>+6,2</a:t>
                       </a:r>
                       <a:endParaRPr lang="en-US" sz="1200" dirty="0"/>
                     </a:p>
@@ -23859,7 +23859,7 @@
                             <a:schemeClr val="accent2"/>
                           </a:solidFill>
                         </a:rPr>
-                        <a:t>+0,4%</a:t>
+                        <a:t>+0,3%</a:t>
                       </a:r>
                       <a:endParaRPr lang="en-US" sz="1200" dirty="0"/>
                     </a:p>

</xml_diff>

<commit_message>
Mostrar valores completos en pesos en el resumen ejecutivo
Las tarjetas muestran la cifra exacta del mes y la del mes anterior, y la
historia del mes usa valores completos. La utilidad mensual toma el valor
impreso en el PDF para coincidir al peso.

Co-Authored-By: Claude Opus 5.5 <noreply@anthropic.com>
Claude-Session: https://claude.ai/code/session_013o6dYMNGXV2KP4Cp5BSjoR
</commit_message>
<xml_diff>
--- a/presentaciones/juridica/Analisis_Financiero_Juridica_Agosto_2026.pptx
+++ b/presentaciones/juridica/Analisis_Financiero_Juridica_Agosto_2026.pptx
@@ -123,18 +123,18 @@
   <p:extLst>
     <p:ext uri="{521415D9-36F7-43E2-AB2F-B90AF26B5E84}">
       <p14:sectionLst xmlns:p14="http://schemas.microsoft.com/office/powerpoint/2010/main">
-        <p14:section name="Portada" id="{bec4d444-e675-d36b-27d7-1d8ee64fcd72}">
+        <p14:section name="Portada" id="{fcbddd0e-f3f2-a262-d71d-b7782a7795ff}">
           <p14:sldIdLst>
             <p14:sldId id="256"/>
             <p14:sldId id="257"/>
           </p14:sldIdLst>
         </p14:section>
-        <p14:section name="1. Resumen ejecutivo" id="{07ee433d-af36-168b-cabd-13e2dbb24797}">
+        <p14:section name="1. Resumen ejecutivo" id="{78a984c2-4017-71e0-4647-46cec65f5b7e}">
           <p14:sldIdLst>
             <p14:sldId id="258"/>
           </p14:sldIdLst>
         </p14:section>
-        <p14:section name="2. Estado de resultados" id="{62c37de3-3898-983f-ad20-630019ac045f}">
+        <p14:section name="2. Estado de resultados" id="{3e71b7c2-a63e-e6d1-e49b-71425c8c0ee0}">
           <p14:sldIdLst>
             <p14:sldId id="259"/>
             <p14:sldId id="260"/>
@@ -143,26 +143,26 @@
             <p14:sldId id="263"/>
           </p14:sldIdLst>
         </p14:section>
-        <p14:section name="3. Ingresos y gastos" id="{b3c4d1af-2130-73f2-48f2-ff14aba22bd6}">
+        <p14:section name="3. Ingresos y gastos" id="{33157e2a-aa1a-9e48-8f96-777bfeaaec36}">
           <p14:sldIdLst>
             <p14:sldId id="264"/>
             <p14:sldId id="265"/>
             <p14:sldId id="266"/>
           </p14:sldIdLst>
         </p14:section>
-        <p14:section name="4. Análisis de causas" id="{1e991dd0-d117-9f6c-096e-b09f00a464a0}">
+        <p14:section name="4. Análisis de causas" id="{5d57cb1d-9c75-2c6d-39db-23fcefdb1bf4}">
           <p14:sldIdLst>
             <p14:sldId id="267"/>
           </p14:sldIdLst>
         </p14:section>
-        <p14:section name="5. Situación financiera" id="{46e91deb-1c01-d316-e402-a3a3f323dd69}">
+        <p14:section name="5. Situación financiera" id="{d2c40b25-08e1-5892-057a-6c823d3a1df7}">
           <p14:sldIdLst>
             <p14:sldId id="268"/>
             <p14:sldId id="269"/>
             <p14:sldId id="270"/>
           </p14:sldIdLst>
         </p14:section>
-        <p14:section name="6. Conclusiones" id="{833ac1c4-8592-7900-b1e6-2aeda0ec5810}">
+        <p14:section name="6. Conclusiones" id="{b4c2aab0-aacc-d8a8-10a8-b3763feb52dc}">
           <p14:sldIdLst>
             <p14:sldId id="271"/>
             <p14:sldId id="272"/>
@@ -6263,7 +6263,7 @@
       </p:sp>
       <p:sp>
         <p:nvSpPr>
-          <p:cNvPr id="4" name="Corte 79"/>
+          <p:cNvPr id="4" name="Corte 83"/>
           <p:cNvSpPr/>
           <p:nvPr/>
         </p:nvSpPr>
@@ -6307,7 +6307,7 @@
       </p:sp>
       <p:sp>
         <p:nvSpPr>
-          <p:cNvPr id="5" name="Mes 80"/>
+          <p:cNvPr id="5" name="Mes 84"/>
           <p:cNvSpPr txBox="1"/>
           <p:nvPr/>
         </p:nvSpPr>
@@ -6343,7 +6343,7 @@
       </p:sp>
       <p:sp>
         <p:nvSpPr>
-          <p:cNvPr id="6" name="Año 81"/>
+          <p:cNvPr id="6" name="Año 85"/>
           <p:cNvSpPr txBox="1"/>
           <p:nvPr/>
         </p:nvSpPr>
@@ -6379,7 +6379,7 @@
       </p:sp>
       <p:sp>
         <p:nvSpPr>
-          <p:cNvPr id="7" name="INGRESOS BRUTOS JULIO 82"/>
+          <p:cNvPr id="7" name="INGRESOS BRUTOS JULIO 86"/>
           <p:cNvSpPr/>
           <p:nvPr/>
         </p:nvSpPr>
@@ -6406,7 +6406,7 @@
       </p:sp>
       <p:sp>
         <p:nvSpPr>
-          <p:cNvPr id="8" name="Etiqueta 83"/>
+          <p:cNvPr id="8" name="Etiqueta 87"/>
           <p:cNvSpPr txBox="1"/>
           <p:nvPr/>
         </p:nvSpPr>
@@ -6442,7 +6442,7 @@
       </p:sp>
       <p:sp>
         <p:nvSpPr>
-          <p:cNvPr id="9" name="Valor 84"/>
+          <p:cNvPr id="9" name="Valor 88"/>
           <p:cNvSpPr txBox="1"/>
           <p:nvPr/>
         </p:nvSpPr>
@@ -6478,7 +6478,7 @@
       </p:sp>
       <p:sp>
         <p:nvSpPr>
-          <p:cNvPr id="10" name="Flecha 85"/>
+          <p:cNvPr id="10" name="Flecha 89"/>
           <p:cNvSpPr/>
           <p:nvPr/>
         </p:nvSpPr>
@@ -6503,7 +6503,7 @@
       </p:sp>
       <p:sp>
         <p:nvSpPr>
-          <p:cNvPr id="11" name="(−) DEVOLUCIONES JULIO 86"/>
+          <p:cNvPr id="11" name="(−) DEVOLUCIONES JULIO 90"/>
           <p:cNvSpPr/>
           <p:nvPr/>
         </p:nvSpPr>
@@ -6530,7 +6530,7 @@
       </p:sp>
       <p:sp>
         <p:nvSpPr>
-          <p:cNvPr id="12" name="Etiqueta 87"/>
+          <p:cNvPr id="12" name="Etiqueta 91"/>
           <p:cNvSpPr txBox="1"/>
           <p:nvPr/>
         </p:nvSpPr>
@@ -6566,7 +6566,7 @@
       </p:sp>
       <p:sp>
         <p:nvSpPr>
-          <p:cNvPr id="13" name="Valor 88"/>
+          <p:cNvPr id="13" name="Valor 92"/>
           <p:cNvSpPr txBox="1"/>
           <p:nvPr/>
         </p:nvSpPr>
@@ -6602,7 +6602,7 @@
       </p:sp>
       <p:sp>
         <p:nvSpPr>
-          <p:cNvPr id="14" name="Flecha 89"/>
+          <p:cNvPr id="14" name="Flecha 93"/>
           <p:cNvSpPr/>
           <p:nvPr/>
         </p:nvSpPr>
@@ -6627,7 +6627,7 @@
       </p:sp>
       <p:sp>
         <p:nvSpPr>
-          <p:cNvPr id="15" name="INGRESOS NETOS JULIO 90"/>
+          <p:cNvPr id="15" name="INGRESOS NETOS JULIO 94"/>
           <p:cNvSpPr/>
           <p:nvPr/>
         </p:nvSpPr>
@@ -6654,7 +6654,7 @@
       </p:sp>
       <p:sp>
         <p:nvSpPr>
-          <p:cNvPr id="16" name="Etiqueta 91"/>
+          <p:cNvPr id="16" name="Etiqueta 95"/>
           <p:cNvSpPr txBox="1"/>
           <p:nvPr/>
         </p:nvSpPr>
@@ -6690,7 +6690,7 @@
       </p:sp>
       <p:sp>
         <p:nvSpPr>
-          <p:cNvPr id="17" name="Valor 92"/>
+          <p:cNvPr id="17" name="Valor 96"/>
           <p:cNvSpPr txBox="1"/>
           <p:nvPr/>
         </p:nvSpPr>
@@ -6726,7 +6726,7 @@
       </p:sp>
       <p:sp>
         <p:nvSpPr>
-          <p:cNvPr id="18" name="Mes 93"/>
+          <p:cNvPr id="18" name="Mes 97"/>
           <p:cNvSpPr txBox="1"/>
           <p:nvPr/>
         </p:nvSpPr>
@@ -6762,7 +6762,7 @@
       </p:sp>
       <p:sp>
         <p:nvSpPr>
-          <p:cNvPr id="19" name="Año 94"/>
+          <p:cNvPr id="19" name="Año 98"/>
           <p:cNvSpPr txBox="1"/>
           <p:nvPr/>
         </p:nvSpPr>
@@ -6798,7 +6798,7 @@
       </p:sp>
       <p:sp>
         <p:nvSpPr>
-          <p:cNvPr id="20" name="INGRESOS BRUTOS AGOSTO 95"/>
+          <p:cNvPr id="20" name="INGRESOS BRUTOS AGOSTO 99"/>
           <p:cNvSpPr/>
           <p:nvPr/>
         </p:nvSpPr>
@@ -6825,7 +6825,7 @@
       </p:sp>
       <p:sp>
         <p:nvSpPr>
-          <p:cNvPr id="21" name="Etiqueta 96"/>
+          <p:cNvPr id="21" name="Etiqueta 100"/>
           <p:cNvSpPr txBox="1"/>
           <p:nvPr/>
         </p:nvSpPr>
@@ -6861,7 +6861,7 @@
       </p:sp>
       <p:sp>
         <p:nvSpPr>
-          <p:cNvPr id="22" name="Valor 97"/>
+          <p:cNvPr id="22" name="Valor 101"/>
           <p:cNvSpPr txBox="1"/>
           <p:nvPr/>
         </p:nvSpPr>
@@ -6897,7 +6897,7 @@
       </p:sp>
       <p:sp>
         <p:nvSpPr>
-          <p:cNvPr id="23" name="Flecha 98"/>
+          <p:cNvPr id="23" name="Flecha 102"/>
           <p:cNvSpPr/>
           <p:nvPr/>
         </p:nvSpPr>
@@ -6922,7 +6922,7 @@
       </p:sp>
       <p:sp>
         <p:nvSpPr>
-          <p:cNvPr id="24" name="(−) DEVOLUCIONES AGOSTO 99"/>
+          <p:cNvPr id="24" name="(−) DEVOLUCIONES AGOSTO 103"/>
           <p:cNvSpPr/>
           <p:nvPr/>
         </p:nvSpPr>
@@ -6949,7 +6949,7 @@
       </p:sp>
       <p:sp>
         <p:nvSpPr>
-          <p:cNvPr id="25" name="Etiqueta 100"/>
+          <p:cNvPr id="25" name="Etiqueta 104"/>
           <p:cNvSpPr txBox="1"/>
           <p:nvPr/>
         </p:nvSpPr>
@@ -6985,7 +6985,7 @@
       </p:sp>
       <p:sp>
         <p:nvSpPr>
-          <p:cNvPr id="26" name="Valor 101"/>
+          <p:cNvPr id="26" name="Valor 105"/>
           <p:cNvSpPr txBox="1"/>
           <p:nvPr/>
         </p:nvSpPr>
@@ -7021,7 +7021,7 @@
       </p:sp>
       <p:sp>
         <p:nvSpPr>
-          <p:cNvPr id="27" name="Flecha 102"/>
+          <p:cNvPr id="27" name="Flecha 106"/>
           <p:cNvSpPr/>
           <p:nvPr/>
         </p:nvSpPr>
@@ -7046,7 +7046,7 @@
       </p:sp>
       <p:sp>
         <p:nvSpPr>
-          <p:cNvPr id="28" name="INGRESOS NETOS AGOSTO 103"/>
+          <p:cNvPr id="28" name="INGRESOS NETOS AGOSTO 107"/>
           <p:cNvSpPr/>
           <p:nvPr/>
         </p:nvSpPr>
@@ -7073,7 +7073,7 @@
       </p:sp>
       <p:sp>
         <p:nvSpPr>
-          <p:cNvPr id="29" name="Etiqueta 104"/>
+          <p:cNvPr id="29" name="Etiqueta 108"/>
           <p:cNvSpPr txBox="1"/>
           <p:nvPr/>
         </p:nvSpPr>
@@ -7109,7 +7109,7 @@
       </p:sp>
       <p:sp>
         <p:nvSpPr>
-          <p:cNvPr id="30" name="Valor 105"/>
+          <p:cNvPr id="30" name="Valor 109"/>
           <p:cNvSpPr txBox="1"/>
           <p:nvPr/>
         </p:nvSpPr>
@@ -7145,7 +7145,7 @@
       </p:sp>
       <p:sp>
         <p:nvSpPr>
-          <p:cNvPr id="31" name="VAR. INGRESOS BRUTOS 106"/>
+          <p:cNvPr id="31" name="VAR. INGRESOS BRUTOS 110"/>
           <p:cNvSpPr/>
           <p:nvPr/>
         </p:nvSpPr>
@@ -7172,7 +7172,7 @@
       </p:sp>
       <p:sp>
         <p:nvSpPr>
-          <p:cNvPr id="32" name="Etiqueta 107"/>
+          <p:cNvPr id="32" name="Etiqueta 111"/>
           <p:cNvSpPr txBox="1"/>
           <p:nvPr/>
         </p:nvSpPr>
@@ -7208,7 +7208,7 @@
       </p:sp>
       <p:sp>
         <p:nvSpPr>
-          <p:cNvPr id="33" name="Valor 108"/>
+          <p:cNvPr id="33" name="Valor 112"/>
           <p:cNvSpPr txBox="1"/>
           <p:nvPr/>
         </p:nvSpPr>
@@ -7244,7 +7244,7 @@
       </p:sp>
       <p:sp>
         <p:nvSpPr>
-          <p:cNvPr id="34" name="Detalle 109"/>
+          <p:cNvPr id="34" name="Detalle 113"/>
           <p:cNvSpPr txBox="1"/>
           <p:nvPr/>
         </p:nvSpPr>
@@ -7280,7 +7280,7 @@
       </p:sp>
       <p:sp>
         <p:nvSpPr>
-          <p:cNvPr id="35" name="VAR. DEVOLUCIONES 110"/>
+          <p:cNvPr id="35" name="VAR. DEVOLUCIONES 114"/>
           <p:cNvSpPr/>
           <p:nvPr/>
         </p:nvSpPr>
@@ -7307,7 +7307,7 @@
       </p:sp>
       <p:sp>
         <p:nvSpPr>
-          <p:cNvPr id="36" name="Etiqueta 111"/>
+          <p:cNvPr id="36" name="Etiqueta 115"/>
           <p:cNvSpPr txBox="1"/>
           <p:nvPr/>
         </p:nvSpPr>
@@ -7343,7 +7343,7 @@
       </p:sp>
       <p:sp>
         <p:nvSpPr>
-          <p:cNvPr id="37" name="Valor 112"/>
+          <p:cNvPr id="37" name="Valor 116"/>
           <p:cNvSpPr txBox="1"/>
           <p:nvPr/>
         </p:nvSpPr>
@@ -7379,7 +7379,7 @@
       </p:sp>
       <p:sp>
         <p:nvSpPr>
-          <p:cNvPr id="38" name="Detalle 113"/>
+          <p:cNvPr id="38" name="Detalle 117"/>
           <p:cNvSpPr txBox="1"/>
           <p:nvPr/>
         </p:nvSpPr>
@@ -7415,7 +7415,7 @@
       </p:sp>
       <p:sp>
         <p:nvSpPr>
-          <p:cNvPr id="39" name="VAR. INGRESOS NETOS 114"/>
+          <p:cNvPr id="39" name="VAR. INGRESOS NETOS 118"/>
           <p:cNvSpPr/>
           <p:nvPr/>
         </p:nvSpPr>
@@ -7442,7 +7442,7 @@
       </p:sp>
       <p:sp>
         <p:nvSpPr>
-          <p:cNvPr id="40" name="Etiqueta 115"/>
+          <p:cNvPr id="40" name="Etiqueta 119"/>
           <p:cNvSpPr txBox="1"/>
           <p:nvPr/>
         </p:nvSpPr>
@@ -7478,7 +7478,7 @@
       </p:sp>
       <p:sp>
         <p:nvSpPr>
-          <p:cNvPr id="41" name="Valor 116"/>
+          <p:cNvPr id="41" name="Valor 120"/>
           <p:cNvSpPr txBox="1"/>
           <p:nvPr/>
         </p:nvSpPr>
@@ -7514,7 +7514,7 @@
       </p:sp>
       <p:sp>
         <p:nvSpPr>
-          <p:cNvPr id="42" name="Detalle 117"/>
+          <p:cNvPr id="42" name="Detalle 121"/>
           <p:cNvSpPr txBox="1"/>
           <p:nvPr/>
         </p:nvSpPr>
@@ -7550,7 +7550,7 @@
       </p:sp>
       <p:sp>
         <p:nvSpPr>
-          <p:cNvPr id="43" name="Var etiqueta 118"/>
+          <p:cNvPr id="43" name="Var etiqueta 122"/>
           <p:cNvSpPr txBox="1"/>
           <p:nvPr/>
         </p:nvSpPr>
@@ -7586,7 +7586,7 @@
       </p:sp>
       <p:sp>
         <p:nvSpPr>
-          <p:cNvPr id="44" name="Nota 119"/>
+          <p:cNvPr id="44" name="Nota 123"/>
           <p:cNvSpPr txBox="1"/>
           <p:nvPr/>
         </p:nvSpPr>
@@ -7768,7 +7768,7 @@
       </p:sp>
       <p:sp>
         <p:nvSpPr>
-          <p:cNvPr id="4" name="Corte 120"/>
+          <p:cNvPr id="4" name="Corte 124"/>
           <p:cNvSpPr/>
           <p:nvPr/>
         </p:nvSpPr>
@@ -9828,7 +9828,7 @@
       </p:graphicFrame>
       <p:sp>
         <p:nvSpPr>
-          <p:cNvPr id="7" name="Concentración 121"/>
+          <p:cNvPr id="7" name="Concentración 125"/>
           <p:cNvSpPr/>
           <p:nvPr/>
         </p:nvSpPr>
@@ -9855,7 +9855,7 @@
       </p:sp>
       <p:sp>
         <p:nvSpPr>
-          <p:cNvPr id="8" name="Concentración título 122"/>
+          <p:cNvPr id="8" name="Concentración título 126"/>
           <p:cNvSpPr txBox="1"/>
           <p:nvPr/>
         </p:nvSpPr>
@@ -9891,7 +9891,7 @@
       </p:sp>
       <p:sp>
         <p:nvSpPr>
-          <p:cNvPr id="9" name="Concentración texto 123"/>
+          <p:cNvPr id="9" name="Concentración texto 127"/>
           <p:cNvSpPr txBox="1"/>
           <p:nvPr/>
         </p:nvSpPr>
@@ -9949,7 +9949,7 @@
       </p:sp>
       <p:sp>
         <p:nvSpPr>
-          <p:cNvPr id="10" name="Nota de color 124"/>
+          <p:cNvPr id="10" name="Nota de color 128"/>
           <p:cNvSpPr txBox="1"/>
           <p:nvPr/>
         </p:nvSpPr>
@@ -10131,7 +10131,7 @@
       </p:sp>
       <p:sp>
         <p:nvSpPr>
-          <p:cNvPr id="4" name="Corte 125"/>
+          <p:cNvPr id="4" name="Corte 129"/>
           <p:cNvSpPr/>
           <p:nvPr/>
         </p:nvSpPr>
@@ -10175,7 +10175,7 @@
       </p:sp>
       <p:sp>
         <p:nvSpPr>
-          <p:cNvPr id="5" name="Factor 01 126"/>
+          <p:cNvPr id="5" name="Factor 01 130"/>
           <p:cNvSpPr/>
           <p:nvPr/>
         </p:nvSpPr>
@@ -10202,7 +10202,7 @@
       </p:sp>
       <p:sp>
         <p:nvSpPr>
-          <p:cNvPr id="6" name="Número 127"/>
+          <p:cNvPr id="6" name="Número 131"/>
           <p:cNvSpPr/>
           <p:nvPr/>
         </p:nvSpPr>
@@ -10244,7 +10244,7 @@
       </p:sp>
       <p:sp>
         <p:nvSpPr>
-          <p:cNvPr id="7" name="Factor título 128"/>
+          <p:cNvPr id="7" name="Factor título 132"/>
           <p:cNvSpPr txBox="1"/>
           <p:nvPr/>
         </p:nvSpPr>
@@ -10280,7 +10280,7 @@
       </p:sp>
       <p:sp>
         <p:nvSpPr>
-          <p:cNvPr id="8" name="Factor JULIO 129"/>
+          <p:cNvPr id="8" name="Factor JULIO 133"/>
           <p:cNvSpPr/>
           <p:nvPr/>
         </p:nvSpPr>
@@ -10307,7 +10307,7 @@
       </p:sp>
       <p:sp>
         <p:nvSpPr>
-          <p:cNvPr id="9" name="Factor mes 130"/>
+          <p:cNvPr id="9" name="Factor mes 134"/>
           <p:cNvSpPr txBox="1"/>
           <p:nvPr/>
         </p:nvSpPr>
@@ -10343,7 +10343,7 @@
       </p:sp>
       <p:sp>
         <p:nvSpPr>
-          <p:cNvPr id="10" name="Factor valor 131"/>
+          <p:cNvPr id="10" name="Factor valor 135"/>
           <p:cNvSpPr txBox="1"/>
           <p:nvPr/>
         </p:nvSpPr>
@@ -10379,7 +10379,7 @@
       </p:sp>
       <p:sp>
         <p:nvSpPr>
-          <p:cNvPr id="11" name="Factor AGOSTO 132"/>
+          <p:cNvPr id="11" name="Factor AGOSTO 136"/>
           <p:cNvSpPr/>
           <p:nvPr/>
         </p:nvSpPr>
@@ -10406,7 +10406,7 @@
       </p:sp>
       <p:sp>
         <p:nvSpPr>
-          <p:cNvPr id="12" name="Factor mes 133"/>
+          <p:cNvPr id="12" name="Factor mes 137"/>
           <p:cNvSpPr txBox="1"/>
           <p:nvPr/>
         </p:nvSpPr>
@@ -10442,7 +10442,7 @@
       </p:sp>
       <p:sp>
         <p:nvSpPr>
-          <p:cNvPr id="13" name="Factor valor 134"/>
+          <p:cNvPr id="13" name="Factor valor 138"/>
           <p:cNvSpPr txBox="1"/>
           <p:nvPr/>
         </p:nvSpPr>
@@ -10478,7 +10478,7 @@
       </p:sp>
       <p:sp>
         <p:nvSpPr>
-          <p:cNvPr id="14" name="Factor detalle 135"/>
+          <p:cNvPr id="14" name="Factor detalle 139"/>
           <p:cNvSpPr txBox="1"/>
           <p:nvPr/>
         </p:nvSpPr>
@@ -10514,7 +10514,7 @@
       </p:sp>
       <p:sp>
         <p:nvSpPr>
-          <p:cNvPr id="15" name="Factor 02 136"/>
+          <p:cNvPr id="15" name="Factor 02 140"/>
           <p:cNvSpPr/>
           <p:nvPr/>
         </p:nvSpPr>
@@ -10541,7 +10541,7 @@
       </p:sp>
       <p:sp>
         <p:nvSpPr>
-          <p:cNvPr id="16" name="Número 137"/>
+          <p:cNvPr id="16" name="Número 141"/>
           <p:cNvSpPr/>
           <p:nvPr/>
         </p:nvSpPr>
@@ -10583,7 +10583,7 @@
       </p:sp>
       <p:sp>
         <p:nvSpPr>
-          <p:cNvPr id="17" name="Factor título 138"/>
+          <p:cNvPr id="17" name="Factor título 142"/>
           <p:cNvSpPr txBox="1"/>
           <p:nvPr/>
         </p:nvSpPr>
@@ -10619,7 +10619,7 @@
       </p:sp>
       <p:sp>
         <p:nvSpPr>
-          <p:cNvPr id="18" name="Factor JULIO 139"/>
+          <p:cNvPr id="18" name="Factor JULIO 143"/>
           <p:cNvSpPr/>
           <p:nvPr/>
         </p:nvSpPr>
@@ -10646,7 +10646,7 @@
       </p:sp>
       <p:sp>
         <p:nvSpPr>
-          <p:cNvPr id="19" name="Factor mes 140"/>
+          <p:cNvPr id="19" name="Factor mes 144"/>
           <p:cNvSpPr txBox="1"/>
           <p:nvPr/>
         </p:nvSpPr>
@@ -10682,7 +10682,7 @@
       </p:sp>
       <p:sp>
         <p:nvSpPr>
-          <p:cNvPr id="20" name="Factor valor 141"/>
+          <p:cNvPr id="20" name="Factor valor 145"/>
           <p:cNvSpPr txBox="1"/>
           <p:nvPr/>
         </p:nvSpPr>
@@ -10718,7 +10718,7 @@
       </p:sp>
       <p:sp>
         <p:nvSpPr>
-          <p:cNvPr id="21" name="Factor AGOSTO 142"/>
+          <p:cNvPr id="21" name="Factor AGOSTO 146"/>
           <p:cNvSpPr/>
           <p:nvPr/>
         </p:nvSpPr>
@@ -10745,7 +10745,7 @@
       </p:sp>
       <p:sp>
         <p:nvSpPr>
-          <p:cNvPr id="22" name="Factor mes 143"/>
+          <p:cNvPr id="22" name="Factor mes 147"/>
           <p:cNvSpPr txBox="1"/>
           <p:nvPr/>
         </p:nvSpPr>
@@ -10781,7 +10781,7 @@
       </p:sp>
       <p:sp>
         <p:nvSpPr>
-          <p:cNvPr id="23" name="Factor valor 144"/>
+          <p:cNvPr id="23" name="Factor valor 148"/>
           <p:cNvSpPr txBox="1"/>
           <p:nvPr/>
         </p:nvSpPr>
@@ -10817,7 +10817,7 @@
       </p:sp>
       <p:sp>
         <p:nvSpPr>
-          <p:cNvPr id="24" name="Factor detalle 145"/>
+          <p:cNvPr id="24" name="Factor detalle 149"/>
           <p:cNvSpPr txBox="1"/>
           <p:nvPr/>
         </p:nvSpPr>
@@ -10853,7 +10853,7 @@
       </p:sp>
       <p:sp>
         <p:nvSpPr>
-          <p:cNvPr id="25" name="Factor 03 146"/>
+          <p:cNvPr id="25" name="Factor 03 150"/>
           <p:cNvSpPr/>
           <p:nvPr/>
         </p:nvSpPr>
@@ -10880,7 +10880,7 @@
       </p:sp>
       <p:sp>
         <p:nvSpPr>
-          <p:cNvPr id="26" name="Número 147"/>
+          <p:cNvPr id="26" name="Número 151"/>
           <p:cNvSpPr/>
           <p:nvPr/>
         </p:nvSpPr>
@@ -10922,7 +10922,7 @@
       </p:sp>
       <p:sp>
         <p:nvSpPr>
-          <p:cNvPr id="27" name="Factor título 148"/>
+          <p:cNvPr id="27" name="Factor título 152"/>
           <p:cNvSpPr txBox="1"/>
           <p:nvPr/>
         </p:nvSpPr>
@@ -10958,7 +10958,7 @@
       </p:sp>
       <p:sp>
         <p:nvSpPr>
-          <p:cNvPr id="28" name="Factor JULIO 149"/>
+          <p:cNvPr id="28" name="Factor JULIO 153"/>
           <p:cNvSpPr/>
           <p:nvPr/>
         </p:nvSpPr>
@@ -10985,7 +10985,7 @@
       </p:sp>
       <p:sp>
         <p:nvSpPr>
-          <p:cNvPr id="29" name="Factor mes 150"/>
+          <p:cNvPr id="29" name="Factor mes 154"/>
           <p:cNvSpPr txBox="1"/>
           <p:nvPr/>
         </p:nvSpPr>
@@ -11021,7 +11021,7 @@
       </p:sp>
       <p:sp>
         <p:nvSpPr>
-          <p:cNvPr id="30" name="Factor valor 151"/>
+          <p:cNvPr id="30" name="Factor valor 155"/>
           <p:cNvSpPr txBox="1"/>
           <p:nvPr/>
         </p:nvSpPr>
@@ -11057,7 +11057,7 @@
       </p:sp>
       <p:sp>
         <p:nvSpPr>
-          <p:cNvPr id="31" name="Factor AGOSTO 152"/>
+          <p:cNvPr id="31" name="Factor AGOSTO 156"/>
           <p:cNvSpPr/>
           <p:nvPr/>
         </p:nvSpPr>
@@ -11084,7 +11084,7 @@
       </p:sp>
       <p:sp>
         <p:nvSpPr>
-          <p:cNvPr id="32" name="Factor mes 153"/>
+          <p:cNvPr id="32" name="Factor mes 157"/>
           <p:cNvSpPr txBox="1"/>
           <p:nvPr/>
         </p:nvSpPr>
@@ -11120,7 +11120,7 @@
       </p:sp>
       <p:sp>
         <p:nvSpPr>
-          <p:cNvPr id="33" name="Factor valor 154"/>
+          <p:cNvPr id="33" name="Factor valor 158"/>
           <p:cNvSpPr txBox="1"/>
           <p:nvPr/>
         </p:nvSpPr>
@@ -11156,7 +11156,7 @@
       </p:sp>
       <p:sp>
         <p:nvSpPr>
-          <p:cNvPr id="34" name="Factor detalle 155"/>
+          <p:cNvPr id="34" name="Factor detalle 159"/>
           <p:cNvSpPr txBox="1"/>
           <p:nvPr/>
         </p:nvSpPr>
@@ -11192,7 +11192,7 @@
       </p:sp>
       <p:sp>
         <p:nvSpPr>
-          <p:cNvPr id="35" name="Lectura clave 156"/>
+          <p:cNvPr id="35" name="Lectura clave 160"/>
           <p:cNvSpPr/>
           <p:nvPr/>
         </p:nvSpPr>
@@ -11219,7 +11219,7 @@
       </p:sp>
       <p:sp>
         <p:nvSpPr>
-          <p:cNvPr id="36" name="Lectura clave texto 157"/>
+          <p:cNvPr id="36" name="Lectura clave texto 161"/>
           <p:cNvSpPr txBox="1"/>
           <p:nvPr/>
         </p:nvSpPr>
@@ -11634,7 +11634,7 @@
       </p:sp>
       <p:sp>
         <p:nvSpPr>
-          <p:cNvPr id="4" name="Corte 158"/>
+          <p:cNvPr id="4" name="Corte 162"/>
           <p:cNvSpPr/>
           <p:nvPr/>
         </p:nvSpPr>
@@ -14699,7 +14699,7 @@
       </p:graphicFrame>
       <p:sp>
         <p:nvSpPr>
-          <p:cNvPr id="6" name="Lectura balance 159"/>
+          <p:cNvPr id="6" name="Lectura balance 163"/>
           <p:cNvSpPr/>
           <p:nvPr/>
         </p:nvSpPr>
@@ -14726,7 +14726,7 @@
       </p:sp>
       <p:sp>
         <p:nvSpPr>
-          <p:cNvPr id="7" name="Lectura balance texto 160"/>
+          <p:cNvPr id="7" name="Lectura balance texto 164"/>
           <p:cNvSpPr txBox="1"/>
           <p:nvPr/>
         </p:nvSpPr>
@@ -14940,7 +14940,7 @@
       </p:sp>
       <p:sp>
         <p:nvSpPr>
-          <p:cNvPr id="4" name="Corte 161"/>
+          <p:cNvPr id="4" name="Corte 165"/>
           <p:cNvSpPr/>
           <p:nvPr/>
         </p:nvSpPr>
@@ -16859,7 +16859,7 @@
       </p:graphicFrame>
       <p:sp>
         <p:nvSpPr>
-          <p:cNvPr id="6" name="Indicador LIQUIDEZ 162"/>
+          <p:cNvPr id="6" name="Indicador LIQUIDEZ 166"/>
           <p:cNvSpPr/>
           <p:nvPr/>
         </p:nvSpPr>
@@ -16886,7 +16886,7 @@
       </p:sp>
       <p:sp>
         <p:nvSpPr>
-          <p:cNvPr id="7" name="Indicador etiqueta 163"/>
+          <p:cNvPr id="7" name="Indicador etiqueta 167"/>
           <p:cNvSpPr txBox="1"/>
           <p:nvPr/>
         </p:nvSpPr>
@@ -16922,7 +16922,7 @@
       </p:sp>
       <p:sp>
         <p:nvSpPr>
-          <p:cNvPr id="8" name="Indicador valor 164"/>
+          <p:cNvPr id="8" name="Indicador valor 168"/>
           <p:cNvSpPr txBox="1"/>
           <p:nvPr/>
         </p:nvSpPr>
@@ -16958,7 +16958,7 @@
       </p:sp>
       <p:sp>
         <p:nvSpPr>
-          <p:cNvPr id="9" name="Indicador detalle 165"/>
+          <p:cNvPr id="9" name="Indicador detalle 169"/>
           <p:cNvSpPr txBox="1"/>
           <p:nvPr/>
         </p:nvSpPr>
@@ -16994,7 +16994,7 @@
       </p:sp>
       <p:sp>
         <p:nvSpPr>
-          <p:cNvPr id="10" name="Indicador SOLIDEZ 166"/>
+          <p:cNvPr id="10" name="Indicador SOLIDEZ 170"/>
           <p:cNvSpPr/>
           <p:nvPr/>
         </p:nvSpPr>
@@ -17021,7 +17021,7 @@
       </p:sp>
       <p:sp>
         <p:nvSpPr>
-          <p:cNvPr id="11" name="Indicador etiqueta 167"/>
+          <p:cNvPr id="11" name="Indicador etiqueta 171"/>
           <p:cNvSpPr txBox="1"/>
           <p:nvPr/>
         </p:nvSpPr>
@@ -17057,7 +17057,7 @@
       </p:sp>
       <p:sp>
         <p:nvSpPr>
-          <p:cNvPr id="12" name="Indicador valor 168"/>
+          <p:cNvPr id="12" name="Indicador valor 172"/>
           <p:cNvSpPr txBox="1"/>
           <p:nvPr/>
         </p:nvSpPr>
@@ -17093,7 +17093,7 @@
       </p:sp>
       <p:sp>
         <p:nvSpPr>
-          <p:cNvPr id="13" name="Indicador detalle 169"/>
+          <p:cNvPr id="13" name="Indicador detalle 173"/>
           <p:cNvSpPr txBox="1"/>
           <p:nvPr/>
         </p:nvSpPr>
@@ -17129,7 +17129,7 @@
       </p:sp>
       <p:sp>
         <p:nvSpPr>
-          <p:cNvPr id="14" name="Indicador RENTABILIDAD 170"/>
+          <p:cNvPr id="14" name="Indicador RENTABILIDAD 174"/>
           <p:cNvSpPr/>
           <p:nvPr/>
         </p:nvSpPr>
@@ -17156,7 +17156,7 @@
       </p:sp>
       <p:sp>
         <p:nvSpPr>
-          <p:cNvPr id="15" name="Indicador etiqueta 171"/>
+          <p:cNvPr id="15" name="Indicador etiqueta 175"/>
           <p:cNvSpPr txBox="1"/>
           <p:nvPr/>
         </p:nvSpPr>
@@ -17192,7 +17192,7 @@
       </p:sp>
       <p:sp>
         <p:nvSpPr>
-          <p:cNvPr id="16" name="Indicador valor 172"/>
+          <p:cNvPr id="16" name="Indicador valor 176"/>
           <p:cNvSpPr txBox="1"/>
           <p:nvPr/>
         </p:nvSpPr>
@@ -17228,7 +17228,7 @@
       </p:sp>
       <p:sp>
         <p:nvSpPr>
-          <p:cNvPr id="17" name="Indicador detalle 173"/>
+          <p:cNvPr id="17" name="Indicador detalle 177"/>
           <p:cNvSpPr txBox="1"/>
           <p:nvPr/>
         </p:nvSpPr>
@@ -17410,7 +17410,7 @@
       </p:sp>
       <p:sp>
         <p:nvSpPr>
-          <p:cNvPr id="4" name="Corte 174"/>
+          <p:cNvPr id="4" name="Corte 178"/>
           <p:cNvSpPr/>
           <p:nvPr/>
         </p:nvSpPr>
@@ -17454,7 +17454,7 @@
       </p:sp>
       <p:sp>
         <p:nvSpPr>
-          <p:cNvPr id="5" name="Conclusión 1 175"/>
+          <p:cNvPr id="5" name="Conclusión 1 179"/>
           <p:cNvSpPr/>
           <p:nvPr/>
         </p:nvSpPr>
@@ -17481,7 +17481,7 @@
       </p:sp>
       <p:sp>
         <p:nvSpPr>
-          <p:cNvPr id="6" name="Número 176"/>
+          <p:cNvPr id="6" name="Número 180"/>
           <p:cNvSpPr/>
           <p:nvPr/>
         </p:nvSpPr>
@@ -17523,7 +17523,7 @@
       </p:sp>
       <p:sp>
         <p:nvSpPr>
-          <p:cNvPr id="7" name="Conclusión texto 177"/>
+          <p:cNvPr id="7" name="Conclusión texto 181"/>
           <p:cNvSpPr txBox="1"/>
           <p:nvPr/>
         </p:nvSpPr>
@@ -17570,7 +17570,7 @@
       </p:sp>
       <p:sp>
         <p:nvSpPr>
-          <p:cNvPr id="8" name="Conclusión 2 178"/>
+          <p:cNvPr id="8" name="Conclusión 2 182"/>
           <p:cNvSpPr/>
           <p:nvPr/>
         </p:nvSpPr>
@@ -17597,7 +17597,7 @@
       </p:sp>
       <p:sp>
         <p:nvSpPr>
-          <p:cNvPr id="9" name="Número 179"/>
+          <p:cNvPr id="9" name="Número 183"/>
           <p:cNvSpPr/>
           <p:nvPr/>
         </p:nvSpPr>
@@ -17639,7 +17639,7 @@
       </p:sp>
       <p:sp>
         <p:nvSpPr>
-          <p:cNvPr id="10" name="Conclusión texto 180"/>
+          <p:cNvPr id="10" name="Conclusión texto 184"/>
           <p:cNvSpPr txBox="1"/>
           <p:nvPr/>
         </p:nvSpPr>
@@ -17686,7 +17686,7 @@
       </p:sp>
       <p:sp>
         <p:nvSpPr>
-          <p:cNvPr id="11" name="Conclusión 3 181"/>
+          <p:cNvPr id="11" name="Conclusión 3 185"/>
           <p:cNvSpPr/>
           <p:nvPr/>
         </p:nvSpPr>
@@ -17713,7 +17713,7 @@
       </p:sp>
       <p:sp>
         <p:nvSpPr>
-          <p:cNvPr id="12" name="Número 182"/>
+          <p:cNvPr id="12" name="Número 186"/>
           <p:cNvSpPr/>
           <p:nvPr/>
         </p:nvSpPr>
@@ -17755,7 +17755,7 @@
       </p:sp>
       <p:sp>
         <p:nvSpPr>
-          <p:cNvPr id="13" name="Conclusión texto 183"/>
+          <p:cNvPr id="13" name="Conclusión texto 187"/>
           <p:cNvSpPr txBox="1"/>
           <p:nvPr/>
         </p:nvSpPr>
@@ -17802,7 +17802,7 @@
       </p:sp>
       <p:sp>
         <p:nvSpPr>
-          <p:cNvPr id="14" name="Conclusión 4 184"/>
+          <p:cNvPr id="14" name="Conclusión 4 188"/>
           <p:cNvSpPr/>
           <p:nvPr/>
         </p:nvSpPr>
@@ -17829,7 +17829,7 @@
       </p:sp>
       <p:sp>
         <p:nvSpPr>
-          <p:cNvPr id="15" name="Número 185"/>
+          <p:cNvPr id="15" name="Número 189"/>
           <p:cNvSpPr/>
           <p:nvPr/>
         </p:nvSpPr>
@@ -17871,7 +17871,7 @@
       </p:sp>
       <p:sp>
         <p:nvSpPr>
-          <p:cNvPr id="16" name="Conclusión texto 186"/>
+          <p:cNvPr id="16" name="Conclusión texto 190"/>
           <p:cNvSpPr txBox="1"/>
           <p:nvPr/>
         </p:nvSpPr>
@@ -17918,7 +17918,7 @@
       </p:sp>
       <p:sp>
         <p:nvSpPr>
-          <p:cNvPr id="17" name="Conclusión 5 187"/>
+          <p:cNvPr id="17" name="Conclusión 5 191"/>
           <p:cNvSpPr/>
           <p:nvPr/>
         </p:nvSpPr>
@@ -17945,7 +17945,7 @@
       </p:sp>
       <p:sp>
         <p:nvSpPr>
-          <p:cNvPr id="18" name="Número 188"/>
+          <p:cNvPr id="18" name="Número 192"/>
           <p:cNvSpPr/>
           <p:nvPr/>
         </p:nvSpPr>
@@ -17987,7 +17987,7 @@
       </p:sp>
       <p:sp>
         <p:nvSpPr>
-          <p:cNvPr id="19" name="Conclusión texto 189"/>
+          <p:cNvPr id="19" name="Conclusión texto 193"/>
           <p:cNvSpPr txBox="1"/>
           <p:nvPr/>
         </p:nvSpPr>
@@ -18104,7 +18104,7 @@
       </p:grpSpPr>
       <p:sp>
         <p:nvSpPr>
-          <p:cNvPr id="2" name="Cierre título 190"/>
+          <p:cNvPr id="2" name="Cierre título 194"/>
           <p:cNvSpPr txBox="1"/>
           <p:nvPr/>
         </p:nvSpPr>
@@ -18140,7 +18140,7 @@
       </p:sp>
       <p:sp>
         <p:nvSpPr>
-          <p:cNvPr id="3" name="Cierre empresa 191"/>
+          <p:cNvPr id="3" name="Cierre empresa 195"/>
           <p:cNvSpPr txBox="1"/>
           <p:nvPr/>
         </p:nvSpPr>
@@ -18176,7 +18176,7 @@
       </p:sp>
       <p:sp>
         <p:nvSpPr>
-          <p:cNvPr id="4" name="Cierre corte 192"/>
+          <p:cNvPr id="4" name="Cierre corte 196"/>
           <p:cNvSpPr txBox="1"/>
           <p:nvPr/>
         </p:nvSpPr>
@@ -18212,7 +18212,7 @@
       </p:sp>
       <p:sp>
         <p:nvSpPr>
-          <p:cNvPr id="5" name="Preparado por 193"/>
+          <p:cNvPr id="5" name="Preparado por 197"/>
           <p:cNvSpPr txBox="1"/>
           <p:nvPr/>
         </p:nvSpPr>
@@ -19435,12 +19435,12 @@
         </p:nvSpPr>
         <p:spPr>
           <a:xfrm>
-            <a:off x="548640" y="1371600"/>
-            <a:ext cx="2633472" cy="1783080"/>
+            <a:off x="548640" y="1325880"/>
+            <a:ext cx="2633472" cy="1965960"/>
           </a:xfrm>
           <a:prstGeom prst="roundRect">
             <a:avLst>
-              <a:gd name="adj" fmla="val 6154"/>
+              <a:gd name="adj" fmla="val 5581"/>
             </a:avLst>
           </a:prstGeom>
           <a:solidFill>
@@ -19462,7 +19462,7 @@
         </p:nvSpPr>
         <p:spPr>
           <a:xfrm>
-            <a:off x="777240" y="1600200"/>
+            <a:off x="777240" y="1508760"/>
             <a:ext cx="2267712" cy="274320"/>
           </a:xfrm>
           <a:prstGeom prst="rect">
@@ -19498,7 +19498,7 @@
         </p:nvSpPr>
         <p:spPr>
           <a:xfrm>
-            <a:off x="777240" y="1901952"/>
+            <a:off x="777240" y="1783080"/>
             <a:ext cx="2267712" cy="548640"/>
           </a:xfrm>
           <a:prstGeom prst="rect">
@@ -19528,14 +19528,50 @@
       </p:sp>
       <p:sp>
         <p:nvSpPr>
-          <p:cNvPr id="8" name="KPI detalle 36"/>
+          <p:cNvPr id="8" name="KPI valor completo 36"/>
           <p:cNvSpPr txBox="1"/>
           <p:nvPr/>
         </p:nvSpPr>
         <p:spPr>
           <a:xfrm>
-            <a:off x="777240" y="2505456"/>
-            <a:ext cx="2267712" cy="237744"/>
+            <a:off x="777240" y="2395728"/>
+            <a:ext cx="2313432" cy="237744"/>
+          </a:xfrm>
+          <a:prstGeom prst="rect">
+            <a:avLst/>
+          </a:prstGeom>
+          <a:noFill/>
+          <a:ln/>
+        </p:spPr>
+        <p:txBody>
+          <a:bodyPr wrap="square" lIns="0" tIns="0" rIns="0" bIns="0" rtlCol="0" anchor="t"/>
+          <a:lstStyle/>
+          <a:p>
+            <a:pPr indent="0" marL="0">
+              <a:buNone/>
+            </a:pPr>
+            <a:r>
+              <a:rPr lang="en-US" sz="1200" b="1" dirty="0">
+                <a:solidFill>
+                  <a:schemeClr val="accent1"/>
+                </a:solidFill>
+              </a:rPr>
+              <a:t>$68.648.289</a:t>
+            </a:r>
+            <a:endParaRPr lang="en-US" sz="1200" dirty="0"/>
+          </a:p>
+        </p:txBody>
+      </p:sp>
+      <p:sp>
+        <p:nvSpPr>
+          <p:cNvPr id="9" name="KPI mes anterior 37"/>
+          <p:cNvSpPr txBox="1"/>
+          <p:nvPr/>
+        </p:nvSpPr>
+        <p:spPr>
+          <a:xfrm>
+            <a:off x="777240" y="2660904"/>
+            <a:ext cx="2313432" cy="237744"/>
           </a:xfrm>
           <a:prstGeom prst="rect">
             <a:avLst/>
@@ -19556,7 +19592,7 @@
                   <a:srgbClr val="5A6572"/>
                 </a:solidFill>
               </a:rPr>
-              <a:t>Julio: $75,0 M</a:t>
+              <a:t>Julio: $75.012.054</a:t>
             </a:r>
             <a:endParaRPr lang="en-US" sz="1200" dirty="0"/>
           </a:p>
@@ -19564,14 +19600,14 @@
       </p:sp>
       <p:sp>
         <p:nvSpPr>
-          <p:cNvPr id="9" name="KPI variación 37"/>
+          <p:cNvPr id="10" name="KPI variación 38"/>
           <p:cNvSpPr txBox="1"/>
           <p:nvPr/>
         </p:nvSpPr>
         <p:spPr>
           <a:xfrm>
-            <a:off x="777240" y="2761488"/>
-            <a:ext cx="2267712" cy="237744"/>
+            <a:off x="777240" y="2926080"/>
+            <a:ext cx="2313432" cy="237744"/>
           </a:xfrm>
           <a:prstGeom prst="rect">
             <a:avLst/>
@@ -19600,18 +19636,18 @@
       </p:sp>
       <p:sp>
         <p:nvSpPr>
-          <p:cNvPr id="10" name="KPI ACTIVO TOTAL 38"/>
+          <p:cNvPr id="11" name="KPI ACTIVO TOTAL 39"/>
           <p:cNvSpPr/>
           <p:nvPr/>
         </p:nvSpPr>
         <p:spPr>
           <a:xfrm>
-            <a:off x="3364992" y="1371600"/>
-            <a:ext cx="2633472" cy="1783080"/>
+            <a:off x="3364992" y="1325880"/>
+            <a:ext cx="2633472" cy="1965960"/>
           </a:xfrm>
           <a:prstGeom prst="roundRect">
             <a:avLst>
-              <a:gd name="adj" fmla="val 6154"/>
+              <a:gd name="adj" fmla="val 5581"/>
             </a:avLst>
           </a:prstGeom>
           <a:solidFill>
@@ -19627,13 +19663,13 @@
       </p:sp>
       <p:sp>
         <p:nvSpPr>
-          <p:cNvPr id="11" name="KPI etiqueta 39"/>
+          <p:cNvPr id="12" name="KPI etiqueta 40"/>
           <p:cNvSpPr txBox="1"/>
           <p:nvPr/>
         </p:nvSpPr>
         <p:spPr>
           <a:xfrm>
-            <a:off x="3593592" y="1600200"/>
+            <a:off x="3593592" y="1508760"/>
             <a:ext cx="2267712" cy="274320"/>
           </a:xfrm>
           <a:prstGeom prst="rect">
@@ -19663,13 +19699,13 @@
       </p:sp>
       <p:sp>
         <p:nvSpPr>
-          <p:cNvPr id="12" name="KPI valor 40"/>
+          <p:cNvPr id="13" name="KPI valor 41"/>
           <p:cNvSpPr txBox="1"/>
           <p:nvPr/>
         </p:nvSpPr>
         <p:spPr>
           <a:xfrm>
-            <a:off x="3593592" y="1901952"/>
+            <a:off x="3593592" y="1783080"/>
             <a:ext cx="2267712" cy="548640"/>
           </a:xfrm>
           <a:prstGeom prst="rect">
@@ -19699,14 +19735,50 @@
       </p:sp>
       <p:sp>
         <p:nvSpPr>
-          <p:cNvPr id="13" name="KPI detalle 41"/>
+          <p:cNvPr id="14" name="KPI valor completo 42"/>
           <p:cNvSpPr txBox="1"/>
           <p:nvPr/>
         </p:nvSpPr>
         <p:spPr>
           <a:xfrm>
-            <a:off x="3593592" y="2505456"/>
-            <a:ext cx="2267712" cy="237744"/>
+            <a:off x="3593592" y="2395728"/>
+            <a:ext cx="2313432" cy="237744"/>
+          </a:xfrm>
+          <a:prstGeom prst="rect">
+            <a:avLst/>
+          </a:prstGeom>
+          <a:noFill/>
+          <a:ln/>
+        </p:spPr>
+        <p:txBody>
+          <a:bodyPr wrap="square" lIns="0" tIns="0" rIns="0" bIns="0" rtlCol="0" anchor="t"/>
+          <a:lstStyle/>
+          <a:p>
+            <a:pPr indent="0" marL="0">
+              <a:buNone/>
+            </a:pPr>
+            <a:r>
+              <a:rPr lang="en-US" sz="1200" b="1" dirty="0">
+                <a:solidFill>
+                  <a:schemeClr val="accent1"/>
+                </a:solidFill>
+              </a:rPr>
+              <a:t>$2.014.089.448</a:t>
+            </a:r>
+            <a:endParaRPr lang="en-US" sz="1200" dirty="0"/>
+          </a:p>
+        </p:txBody>
+      </p:sp>
+      <p:sp>
+        <p:nvSpPr>
+          <p:cNvPr id="15" name="KPI mes anterior 43"/>
+          <p:cNvSpPr txBox="1"/>
+          <p:nvPr/>
+        </p:nvSpPr>
+        <p:spPr>
+          <a:xfrm>
+            <a:off x="3593592" y="2660904"/>
+            <a:ext cx="2313432" cy="237744"/>
           </a:xfrm>
           <a:prstGeom prst="rect">
             <a:avLst/>
@@ -19727,7 +19799,7 @@
                   <a:srgbClr val="5A6572"/>
                 </a:solidFill>
               </a:rPr>
-              <a:t>Julio: $1.973,2 M</a:t>
+              <a:t>Julio: $1.973.169.245</a:t>
             </a:r>
             <a:endParaRPr lang="en-US" sz="1200" dirty="0"/>
           </a:p>
@@ -19735,14 +19807,14 @@
       </p:sp>
       <p:sp>
         <p:nvSpPr>
-          <p:cNvPr id="14" name="KPI variación 42"/>
+          <p:cNvPr id="16" name="KPI variación 44"/>
           <p:cNvSpPr txBox="1"/>
           <p:nvPr/>
         </p:nvSpPr>
         <p:spPr>
           <a:xfrm>
-            <a:off x="3593592" y="2761488"/>
-            <a:ext cx="2267712" cy="237744"/>
+            <a:off x="3593592" y="2926080"/>
+            <a:ext cx="2313432" cy="237744"/>
           </a:xfrm>
           <a:prstGeom prst="rect">
             <a:avLst/>
@@ -19771,18 +19843,18 @@
       </p:sp>
       <p:sp>
         <p:nvSpPr>
-          <p:cNvPr id="15" name="KPI PATRIMONIO 43"/>
+          <p:cNvPr id="17" name="KPI PATRIMONIO 45"/>
           <p:cNvSpPr/>
           <p:nvPr/>
         </p:nvSpPr>
         <p:spPr>
           <a:xfrm>
-            <a:off x="6181344" y="1371600"/>
-            <a:ext cx="2633472" cy="1783080"/>
+            <a:off x="6181344" y="1325880"/>
+            <a:ext cx="2633472" cy="1965960"/>
           </a:xfrm>
           <a:prstGeom prst="roundRect">
             <a:avLst>
-              <a:gd name="adj" fmla="val 6154"/>
+              <a:gd name="adj" fmla="val 5581"/>
             </a:avLst>
           </a:prstGeom>
           <a:solidFill>
@@ -19798,13 +19870,13 @@
       </p:sp>
       <p:sp>
         <p:nvSpPr>
-          <p:cNvPr id="16" name="KPI etiqueta 44"/>
+          <p:cNvPr id="18" name="KPI etiqueta 46"/>
           <p:cNvSpPr txBox="1"/>
           <p:nvPr/>
         </p:nvSpPr>
         <p:spPr>
           <a:xfrm>
-            <a:off x="6409944" y="1600200"/>
+            <a:off x="6409944" y="1508760"/>
             <a:ext cx="2267712" cy="274320"/>
           </a:xfrm>
           <a:prstGeom prst="rect">
@@ -19834,13 +19906,13 @@
       </p:sp>
       <p:sp>
         <p:nvSpPr>
-          <p:cNvPr id="17" name="KPI valor 45"/>
+          <p:cNvPr id="19" name="KPI valor 47"/>
           <p:cNvSpPr txBox="1"/>
           <p:nvPr/>
         </p:nvSpPr>
         <p:spPr>
           <a:xfrm>
-            <a:off x="6409944" y="1901952"/>
+            <a:off x="6409944" y="1783080"/>
             <a:ext cx="2267712" cy="548640"/>
           </a:xfrm>
           <a:prstGeom prst="rect">
@@ -19870,14 +19942,50 @@
       </p:sp>
       <p:sp>
         <p:nvSpPr>
-          <p:cNvPr id="18" name="KPI detalle 46"/>
+          <p:cNvPr id="20" name="KPI valor completo 48"/>
           <p:cNvSpPr txBox="1"/>
           <p:nvPr/>
         </p:nvSpPr>
         <p:spPr>
           <a:xfrm>
-            <a:off x="6409944" y="2505456"/>
-            <a:ext cx="2267712" cy="237744"/>
+            <a:off x="6409944" y="2395728"/>
+            <a:ext cx="2313432" cy="237744"/>
+          </a:xfrm>
+          <a:prstGeom prst="rect">
+            <a:avLst/>
+          </a:prstGeom>
+          <a:noFill/>
+          <a:ln/>
+        </p:spPr>
+        <p:txBody>
+          <a:bodyPr wrap="square" lIns="0" tIns="0" rIns="0" bIns="0" rtlCol="0" anchor="t"/>
+          <a:lstStyle/>
+          <a:p>
+            <a:pPr indent="0" marL="0">
+              <a:buNone/>
+            </a:pPr>
+            <a:r>
+              <a:rPr lang="en-US" sz="1200" b="1" dirty="0">
+                <a:solidFill>
+                  <a:schemeClr val="accent1"/>
+                </a:solidFill>
+              </a:rPr>
+              <a:t>$1.819.253.399</a:t>
+            </a:r>
+            <a:endParaRPr lang="en-US" sz="1200" dirty="0"/>
+          </a:p>
+        </p:txBody>
+      </p:sp>
+      <p:sp>
+        <p:nvSpPr>
+          <p:cNvPr id="21" name="KPI mes anterior 49"/>
+          <p:cNvSpPr txBox="1"/>
+          <p:nvPr/>
+        </p:nvSpPr>
+        <p:spPr>
+          <a:xfrm>
+            <a:off x="6409944" y="2660904"/>
+            <a:ext cx="2313432" cy="237744"/>
           </a:xfrm>
           <a:prstGeom prst="rect">
             <a:avLst/>
@@ -19898,7 +20006,7 @@
                   <a:srgbClr val="5A6572"/>
                 </a:solidFill>
               </a:rPr>
-              <a:t>Julio: $1.813,1 M</a:t>
+              <a:t>Julio: $1.813.066.565</a:t>
             </a:r>
             <a:endParaRPr lang="en-US" sz="1200" dirty="0"/>
           </a:p>
@@ -19906,14 +20014,14 @@
       </p:sp>
       <p:sp>
         <p:nvSpPr>
-          <p:cNvPr id="19" name="KPI variación 47"/>
+          <p:cNvPr id="22" name="KPI variación 50"/>
           <p:cNvSpPr txBox="1"/>
           <p:nvPr/>
         </p:nvSpPr>
         <p:spPr>
           <a:xfrm>
-            <a:off x="6409944" y="2761488"/>
-            <a:ext cx="2267712" cy="237744"/>
+            <a:off x="6409944" y="2926080"/>
+            <a:ext cx="2313432" cy="237744"/>
           </a:xfrm>
           <a:prstGeom prst="rect">
             <a:avLst/>
@@ -19942,18 +20050,18 @@
       </p:sp>
       <p:sp>
         <p:nvSpPr>
-          <p:cNvPr id="20" name="KPI UTILIDAD NETA 48"/>
+          <p:cNvPr id="23" name="KPI UTILIDAD NETA 51"/>
           <p:cNvSpPr/>
           <p:nvPr/>
         </p:nvSpPr>
         <p:spPr>
           <a:xfrm>
-            <a:off x="8997696" y="1371600"/>
-            <a:ext cx="2633472" cy="1783080"/>
+            <a:off x="8997696" y="1325880"/>
+            <a:ext cx="2633472" cy="1965960"/>
           </a:xfrm>
           <a:prstGeom prst="roundRect">
             <a:avLst>
-              <a:gd name="adj" fmla="val 6154"/>
+              <a:gd name="adj" fmla="val 5581"/>
             </a:avLst>
           </a:prstGeom>
           <a:solidFill>
@@ -19969,13 +20077,13 @@
       </p:sp>
       <p:sp>
         <p:nvSpPr>
-          <p:cNvPr id="21" name="KPI etiqueta 49"/>
+          <p:cNvPr id="24" name="KPI etiqueta 52"/>
           <p:cNvSpPr txBox="1"/>
           <p:nvPr/>
         </p:nvSpPr>
         <p:spPr>
           <a:xfrm>
-            <a:off x="9226296" y="1600200"/>
+            <a:off x="9226296" y="1508760"/>
             <a:ext cx="2267712" cy="274320"/>
           </a:xfrm>
           <a:prstGeom prst="rect">
@@ -20005,13 +20113,13 @@
       </p:sp>
       <p:sp>
         <p:nvSpPr>
-          <p:cNvPr id="22" name="KPI valor 50"/>
+          <p:cNvPr id="25" name="KPI valor 53"/>
           <p:cNvSpPr txBox="1"/>
           <p:nvPr/>
         </p:nvSpPr>
         <p:spPr>
           <a:xfrm>
-            <a:off x="9226296" y="1901952"/>
+            <a:off x="9226296" y="1783080"/>
             <a:ext cx="2267712" cy="548640"/>
           </a:xfrm>
           <a:prstGeom prst="rect">
@@ -20041,14 +20149,50 @@
       </p:sp>
       <p:sp>
         <p:nvSpPr>
-          <p:cNvPr id="23" name="KPI detalle 51"/>
+          <p:cNvPr id="26" name="KPI valor completo 54"/>
           <p:cNvSpPr txBox="1"/>
           <p:nvPr/>
         </p:nvSpPr>
         <p:spPr>
           <a:xfrm>
-            <a:off x="9226296" y="2505456"/>
-            <a:ext cx="2267712" cy="237744"/>
+            <a:off x="9226296" y="2395728"/>
+            <a:ext cx="2313432" cy="237744"/>
+          </a:xfrm>
+          <a:prstGeom prst="rect">
+            <a:avLst/>
+          </a:prstGeom>
+          <a:noFill/>
+          <a:ln/>
+        </p:spPr>
+        <p:txBody>
+          <a:bodyPr wrap="square" lIns="0" tIns="0" rIns="0" bIns="0" rtlCol="0" anchor="t"/>
+          <a:lstStyle/>
+          <a:p>
+            <a:pPr indent="0" marL="0">
+              <a:buNone/>
+            </a:pPr>
+            <a:r>
+              <a:rPr lang="en-US" sz="1200" b="1" dirty="0">
+                <a:solidFill>
+                  <a:schemeClr val="bg1"/>
+                </a:solidFill>
+              </a:rPr>
+              <a:t>$6.186.833 · margen 9,0%</a:t>
+            </a:r>
+            <a:endParaRPr lang="en-US" sz="1200" dirty="0"/>
+          </a:p>
+        </p:txBody>
+      </p:sp>
+      <p:sp>
+        <p:nvSpPr>
+          <p:cNvPr id="27" name="KPI mes anterior 55"/>
+          <p:cNvSpPr txBox="1"/>
+          <p:nvPr/>
+        </p:nvSpPr>
+        <p:spPr>
+          <a:xfrm>
+            <a:off x="9226296" y="2660904"/>
+            <a:ext cx="2313432" cy="237744"/>
           </a:xfrm>
           <a:prstGeom prst="rect">
             <a:avLst/>
@@ -20069,7 +20213,7 @@
                   <a:schemeClr val="accent3"/>
                 </a:solidFill>
               </a:rPr>
-              <a:t>Margen neto 9,0%</a:t>
+              <a:t>Julio: $27.205.730</a:t>
             </a:r>
             <a:endParaRPr lang="en-US" sz="1200" dirty="0"/>
           </a:p>
@@ -20077,14 +20221,14 @@
       </p:sp>
       <p:sp>
         <p:nvSpPr>
-          <p:cNvPr id="24" name="KPI variación 52"/>
+          <p:cNvPr id="28" name="KPI variación 56"/>
           <p:cNvSpPr txBox="1"/>
           <p:nvPr/>
         </p:nvSpPr>
         <p:spPr>
           <a:xfrm>
-            <a:off x="9226296" y="2761488"/>
-            <a:ext cx="2267712" cy="237744"/>
+            <a:off x="9226296" y="2926080"/>
+            <a:ext cx="2313432" cy="237744"/>
           </a:xfrm>
           <a:prstGeom prst="rect">
             <a:avLst/>
@@ -20105,7 +20249,7 @@
                   <a:schemeClr val="bg1"/>
                 </a:solidFill>
               </a:rPr>
-              <a:t>Julio: $27,2 M  (−77,3%)</a:t>
+              <a:t>▼ −77,3% vs. julio</a:t>
             </a:r>
             <a:endParaRPr lang="en-US" sz="1200" dirty="0"/>
           </a:p>
@@ -20113,13 +20257,13 @@
       </p:sp>
       <p:graphicFrame>
         <p:nvGraphicFramePr>
-          <p:cNvPr id="25" name="Gráfico comparativo" descr=""/>
+          <p:cNvPr id="29" name="Gráfico comparativo" descr=""/>
           <p:cNvGraphicFramePr/>
           <p:nvPr/>
         </p:nvGraphicFramePr>
         <p:xfrm>
-          <a:off x="548640" y="3383280"/>
-          <a:ext cx="6949440" cy="2788920"/>
+          <a:off x="548640" y="3520440"/>
+          <a:ext cx="6949440" cy="2651760"/>
         </p:xfrm>
         <a:graphic xmlns:a="http://schemas.openxmlformats.org/drawingml/2006/main">
           <a:graphicData uri="http://schemas.openxmlformats.org/drawingml/2006/chart">
@@ -20129,18 +20273,18 @@
       </p:graphicFrame>
       <p:sp>
         <p:nvSpPr>
-          <p:cNvPr id="26" name="Lectura del mes 53"/>
+          <p:cNvPr id="30" name="Lectura del mes 57"/>
           <p:cNvSpPr/>
           <p:nvPr/>
         </p:nvSpPr>
         <p:spPr>
           <a:xfrm>
-            <a:off x="7726680" y="3383280"/>
-            <a:ext cx="3904488" cy="2788920"/>
+            <a:off x="7726680" y="3520440"/>
+            <a:ext cx="3904488" cy="2651760"/>
           </a:xfrm>
           <a:prstGeom prst="roundRect">
             <a:avLst>
-              <a:gd name="adj" fmla="val 3934"/>
+              <a:gd name="adj" fmla="val 4138"/>
             </a:avLst>
           </a:prstGeom>
           <a:solidFill>
@@ -20156,13 +20300,13 @@
       </p:sp>
       <p:sp>
         <p:nvSpPr>
-          <p:cNvPr id="27" name="Lectura título 54"/>
+          <p:cNvPr id="31" name="Lectura título 58"/>
           <p:cNvSpPr txBox="1"/>
           <p:nvPr/>
         </p:nvSpPr>
         <p:spPr>
           <a:xfrm>
-            <a:off x="8001000" y="3611880"/>
+            <a:off x="8001000" y="3675888"/>
             <a:ext cx="3383280" cy="347472"/>
           </a:xfrm>
           <a:prstGeom prst="rect">
@@ -20192,14 +20336,14 @@
       </p:sp>
       <p:sp>
         <p:nvSpPr>
-          <p:cNvPr id="28" name="Lectura texto 55"/>
+          <p:cNvPr id="32" name="Lectura texto 59"/>
           <p:cNvSpPr txBox="1"/>
           <p:nvPr/>
         </p:nvSpPr>
         <p:spPr>
           <a:xfrm>
-            <a:off x="8001000" y="4041648"/>
-            <a:ext cx="3383280" cy="2011680"/>
+            <a:off x="8001000" y="4087368"/>
+            <a:ext cx="3429000" cy="2011680"/>
           </a:xfrm>
           <a:prstGeom prst="rect">
             <a:avLst/>
@@ -20218,14 +20362,14 @@
               <a:buNone/>
             </a:pPr>
             <a:r>
-              <a:rPr lang="en-US" sz="1300" dirty="0">
+              <a:rPr lang="en-US" sz="1200" dirty="0">
                 <a:solidFill>
                   <a:schemeClr val="tx1"/>
                 </a:solidFill>
               </a:rPr>
-              <a:t>Los ingresos netos bajaron 8,5% en agosto y la utilidad neta cayó 77,3%, hasta $6,2 M.</a:t>
+              <a:t>Los ingresos netos bajaron 8,5% en agosto ($68.648.289 frente a $75.012.054 en julio) y la utilidad neta cayó 77,3%, hasta $6.186.833.</a:t>
             </a:r>
-            <a:endParaRPr lang="en-US" sz="1300" dirty="0"/>
+            <a:endParaRPr lang="en-US" sz="1200" dirty="0"/>
           </a:p>
           <a:p>
             <a:pPr indent="0" marL="0">
@@ -20235,14 +20379,14 @@
               <a:buNone/>
             </a:pPr>
             <a:r>
-              <a:rPr lang="en-US" sz="1300" dirty="0">
+              <a:rPr lang="en-US" sz="1200" dirty="0">
                 <a:solidFill>
                   <a:schemeClr val="tx1"/>
                 </a:solidFill>
               </a:rPr>
-              <a:t>La causa principal es el pago bimestral del impuesto SIMPLE ($22,9 M), que julio no tuvo: antes de impuestos agosto ganó $29,1 M, 6,8% más que julio, gracias a un mejor resultado neto de la Unión Temporal.</a:t>
+              <a:t>La causa principal es el pago bimestral del impuesto SIMPLE ($22.869.000), que julio no tuvo: antes de impuestos agosto ganó $29.055.833, 6,8% más que julio, gracias a un mejor resultado neto de la Unión Temporal.</a:t>
             </a:r>
-            <a:endParaRPr lang="en-US" sz="1300" dirty="0"/>
+            <a:endParaRPr lang="en-US" sz="1200" dirty="0"/>
           </a:p>
         </p:txBody>
       </p:sp>
@@ -20616,7 +20760,7 @@
       </p:sp>
       <p:sp>
         <p:nvSpPr>
-          <p:cNvPr id="4" name="Corte 56"/>
+          <p:cNvPr id="4" name="Corte 60"/>
           <p:cNvSpPr/>
           <p:nvPr/>
         </p:nvSpPr>
@@ -23913,7 +24057,7 @@
       </p:graphicFrame>
       <p:sp>
         <p:nvSpPr>
-          <p:cNvPr id="6" name="Nota de color 57"/>
+          <p:cNvPr id="6" name="Nota de color 61"/>
           <p:cNvSpPr txBox="1"/>
           <p:nvPr/>
         </p:nvSpPr>
@@ -24095,7 +24239,7 @@
       </p:sp>
       <p:sp>
         <p:nvSpPr>
-          <p:cNvPr id="4" name="Corte 58"/>
+          <p:cNvPr id="4" name="Corte 62"/>
           <p:cNvSpPr/>
           <p:nvPr/>
         </p:nvSpPr>
@@ -24155,7 +24299,7 @@
       </p:graphicFrame>
       <p:sp>
         <p:nvSpPr>
-          <p:cNvPr id="6" name="Lectura del puente 59"/>
+          <p:cNvPr id="6" name="Lectura del puente 63"/>
           <p:cNvSpPr/>
           <p:nvPr/>
         </p:nvSpPr>
@@ -24182,7 +24326,7 @@
       </p:sp>
       <p:sp>
         <p:nvSpPr>
-          <p:cNvPr id="7" name="Puente título 60"/>
+          <p:cNvPr id="7" name="Puente título 64"/>
           <p:cNvSpPr txBox="1"/>
           <p:nvPr/>
         </p:nvSpPr>
@@ -24218,7 +24362,7 @@
       </p:sp>
       <p:sp>
         <p:nvSpPr>
-          <p:cNvPr id="8" name="Puente texto 61"/>
+          <p:cNvPr id="8" name="Puente texto 65"/>
           <p:cNvSpPr txBox="1"/>
           <p:nvPr/>
         </p:nvSpPr>
@@ -24498,7 +24642,7 @@
       </p:sp>
       <p:sp>
         <p:nvSpPr>
-          <p:cNvPr id="4" name="Corte 62"/>
+          <p:cNvPr id="4" name="Corte 66"/>
           <p:cNvSpPr/>
           <p:nvPr/>
         </p:nvSpPr>
@@ -27050,7 +27194,7 @@
       </p:graphicFrame>
       <p:sp>
         <p:nvSpPr>
-          <p:cNvPr id="7" name="Tendencia 63"/>
+          <p:cNvPr id="7" name="Tendencia 67"/>
           <p:cNvSpPr/>
           <p:nvPr/>
         </p:nvSpPr>
@@ -27077,7 +27221,7 @@
       </p:sp>
       <p:sp>
         <p:nvSpPr>
-          <p:cNvPr id="8" name="Tendencia valor 64"/>
+          <p:cNvPr id="8" name="Tendencia valor 68"/>
           <p:cNvSpPr txBox="1"/>
           <p:nvPr/>
         </p:nvSpPr>
@@ -27113,7 +27257,7 @@
       </p:sp>
       <p:sp>
         <p:nvSpPr>
-          <p:cNvPr id="9" name="Tendencia texto 65"/>
+          <p:cNvPr id="9" name="Tendencia texto 69"/>
           <p:cNvSpPr txBox="1"/>
           <p:nvPr/>
         </p:nvSpPr>
@@ -27295,7 +27439,7 @@
       </p:sp>
       <p:sp>
         <p:nvSpPr>
-          <p:cNvPr id="4" name="Corte 66"/>
+          <p:cNvPr id="4" name="Corte 70"/>
           <p:cNvSpPr/>
           <p:nvPr/>
         </p:nvSpPr>
@@ -27355,7 +27499,7 @@
       </p:graphicFrame>
       <p:sp>
         <p:nvSpPr>
-          <p:cNvPr id="6" name="KPI MARGEN BRUTO 67"/>
+          <p:cNvPr id="6" name="KPI MARGEN BRUTO 71"/>
           <p:cNvSpPr/>
           <p:nvPr/>
         </p:nvSpPr>
@@ -27382,7 +27526,7 @@
       </p:sp>
       <p:sp>
         <p:nvSpPr>
-          <p:cNvPr id="7" name="KPI etiqueta 68"/>
+          <p:cNvPr id="7" name="KPI etiqueta 72"/>
           <p:cNvSpPr txBox="1"/>
           <p:nvPr/>
         </p:nvSpPr>
@@ -27418,7 +27562,7 @@
       </p:sp>
       <p:sp>
         <p:nvSpPr>
-          <p:cNvPr id="8" name="KPI valor 69"/>
+          <p:cNvPr id="8" name="KPI valor 73"/>
           <p:cNvSpPr txBox="1"/>
           <p:nvPr/>
         </p:nvSpPr>
@@ -27454,7 +27598,7 @@
       </p:sp>
       <p:sp>
         <p:nvSpPr>
-          <p:cNvPr id="9" name="KPI detalle 70"/>
+          <p:cNvPr id="9" name="KPI detalle 74"/>
           <p:cNvSpPr txBox="1"/>
           <p:nvPr/>
         </p:nvSpPr>
@@ -27490,7 +27634,7 @@
       </p:sp>
       <p:sp>
         <p:nvSpPr>
-          <p:cNvPr id="10" name="KPI MARGEN OPERACIONAL 71"/>
+          <p:cNvPr id="10" name="KPI MARGEN OPERACIONAL 75"/>
           <p:cNvSpPr/>
           <p:nvPr/>
         </p:nvSpPr>
@@ -27517,7 +27661,7 @@
       </p:sp>
       <p:sp>
         <p:nvSpPr>
-          <p:cNvPr id="11" name="KPI etiqueta 72"/>
+          <p:cNvPr id="11" name="KPI etiqueta 76"/>
           <p:cNvSpPr txBox="1"/>
           <p:nvPr/>
         </p:nvSpPr>
@@ -27553,7 +27697,7 @@
       </p:sp>
       <p:sp>
         <p:nvSpPr>
-          <p:cNvPr id="12" name="KPI valor 73"/>
+          <p:cNvPr id="12" name="KPI valor 77"/>
           <p:cNvSpPr txBox="1"/>
           <p:nvPr/>
         </p:nvSpPr>
@@ -27589,7 +27733,7 @@
       </p:sp>
       <p:sp>
         <p:nvSpPr>
-          <p:cNvPr id="13" name="KPI detalle 74"/>
+          <p:cNvPr id="13" name="KPI detalle 78"/>
           <p:cNvSpPr txBox="1"/>
           <p:nvPr/>
         </p:nvSpPr>
@@ -27625,7 +27769,7 @@
       </p:sp>
       <p:sp>
         <p:nvSpPr>
-          <p:cNvPr id="14" name="KPI MARGEN NETO 75"/>
+          <p:cNvPr id="14" name="KPI MARGEN NETO 79"/>
           <p:cNvSpPr/>
           <p:nvPr/>
         </p:nvSpPr>
@@ -27652,7 +27796,7 @@
       </p:sp>
       <p:sp>
         <p:nvSpPr>
-          <p:cNvPr id="15" name="KPI etiqueta 76"/>
+          <p:cNvPr id="15" name="KPI etiqueta 80"/>
           <p:cNvSpPr txBox="1"/>
           <p:nvPr/>
         </p:nvSpPr>
@@ -27688,7 +27832,7 @@
       </p:sp>
       <p:sp>
         <p:nvSpPr>
-          <p:cNvPr id="16" name="KPI valor 77"/>
+          <p:cNvPr id="16" name="KPI valor 81"/>
           <p:cNvSpPr txBox="1"/>
           <p:nvPr/>
         </p:nvSpPr>
@@ -27724,7 +27868,7 @@
       </p:sp>
       <p:sp>
         <p:nvSpPr>
-          <p:cNvPr id="17" name="KPI detalle 78"/>
+          <p:cNvPr id="17" name="KPI detalle 82"/>
           <p:cNvSpPr txBox="1"/>
           <p:nvPr/>
         </p:nvSpPr>

</xml_diff>

<commit_message>
Usar valores completos en pesos en tablas, tarjetas y textos
Los gráficos siguen en millones; tablas, tarjetas y lecturas muestran la
cifra exacta del PDF. El resultado antes de impuesto y la utilidad del año
toman el valor impreso para coincidir al peso.

Co-Authored-By: Claude Opus 5.5 <noreply@anthropic.com>
Claude-Session: https://claude.ai/code/session_013o6dYMNGXV2KP4Cp5BSjoR
</commit_message>
<xml_diff>
--- a/presentaciones/juridica/Analisis_Financiero_Juridica_Agosto_2026.pptx
+++ b/presentaciones/juridica/Analisis_Financiero_Juridica_Agosto_2026.pptx
@@ -123,18 +123,18 @@
   <p:extLst>
     <p:ext uri="{521415D9-36F7-43E2-AB2F-B90AF26B5E84}">
       <p14:sectionLst xmlns:p14="http://schemas.microsoft.com/office/powerpoint/2010/main">
-        <p14:section name="Portada" id="{fcbddd0e-f3f2-a262-d71d-b7782a7795ff}">
+        <p14:section name="Portada" id="{4c935de0-6842-b710-408e-a8a6e9b8638e}">
           <p14:sldIdLst>
             <p14:sldId id="256"/>
             <p14:sldId id="257"/>
           </p14:sldIdLst>
         </p14:section>
-        <p14:section name="1. Resumen ejecutivo" id="{78a984c2-4017-71e0-4647-46cec65f5b7e}">
+        <p14:section name="1. Resumen ejecutivo" id="{10e38c37-da0b-8c0a-9a63-f6ea0bb0d2c7}">
           <p14:sldIdLst>
             <p14:sldId id="258"/>
           </p14:sldIdLst>
         </p14:section>
-        <p14:section name="2. Estado de resultados" id="{3e71b7c2-a63e-e6d1-e49b-71425c8c0ee0}">
+        <p14:section name="2. Estado de resultados" id="{9ce27edf-75a2-b8d2-a094-f7e74d400283}">
           <p14:sldIdLst>
             <p14:sldId id="259"/>
             <p14:sldId id="260"/>
@@ -143,26 +143,26 @@
             <p14:sldId id="263"/>
           </p14:sldIdLst>
         </p14:section>
-        <p14:section name="3. Ingresos y gastos" id="{33157e2a-aa1a-9e48-8f96-777bfeaaec36}">
+        <p14:section name="3. Ingresos y gastos" id="{ec24b380-13ba-fb02-ded8-8c487600bb52}">
           <p14:sldIdLst>
             <p14:sldId id="264"/>
             <p14:sldId id="265"/>
             <p14:sldId id="266"/>
           </p14:sldIdLst>
         </p14:section>
-        <p14:section name="4. Análisis de causas" id="{5d57cb1d-9c75-2c6d-39db-23fcefdb1bf4}">
+        <p14:section name="4. Análisis de causas" id="{b8a5a307-6f96-9b4f-9c99-970b330962ab}">
           <p14:sldIdLst>
             <p14:sldId id="267"/>
           </p14:sldIdLst>
         </p14:section>
-        <p14:section name="5. Situación financiera" id="{d2c40b25-08e1-5892-057a-6c823d3a1df7}">
+        <p14:section name="5. Situación financiera" id="{034e84f6-88d2-4692-4d8b-b0d74467a322}">
           <p14:sldIdLst>
             <p14:sldId id="268"/>
             <p14:sldId id="269"/>
             <p14:sldId id="270"/>
           </p14:sldIdLst>
         </p14:section>
-        <p14:section name="6. Conclusiones" id="{b4c2aab0-aacc-d8a8-10a8-b3763feb52dc}">
+        <p14:section name="6. Conclusiones" id="{50278fd8-c818-b80a-0910-921e35922bef}">
           <p14:sldIdLst>
             <p14:sldId id="271"/>
             <p14:sldId id="272"/>
@@ -6465,14 +6465,14 @@
               <a:buNone/>
             </a:pPr>
             <a:r>
-              <a:rPr lang="en-US" sz="3000" b="1" dirty="0">
+              <a:rPr lang="en-US" sz="2600" b="1" dirty="0">
                 <a:solidFill>
                   <a:schemeClr val="accent1"/>
                 </a:solidFill>
               </a:rPr>
-              <a:t>$91,4 M</a:t>
+              <a:t>$91.410.054</a:t>
             </a:r>
-            <a:endParaRPr lang="en-US" sz="3000" dirty="0"/>
+            <a:endParaRPr lang="en-US" sz="2600" dirty="0"/>
           </a:p>
         </p:txBody>
       </p:sp>
@@ -6589,14 +6589,14 @@
               <a:buNone/>
             </a:pPr>
             <a:r>
-              <a:rPr lang="en-US" sz="3000" b="1" dirty="0">
+              <a:rPr lang="en-US" sz="2600" b="1" dirty="0">
                 <a:solidFill>
                   <a:schemeClr val="accent6"/>
                 </a:solidFill>
               </a:rPr>
-              <a:t>-$16,4 M</a:t>
+              <a:t>-$16.398.000</a:t>
             </a:r>
-            <a:endParaRPr lang="en-US" sz="3000" dirty="0"/>
+            <a:endParaRPr lang="en-US" sz="2600" dirty="0"/>
           </a:p>
         </p:txBody>
       </p:sp>
@@ -6713,14 +6713,14 @@
               <a:buNone/>
             </a:pPr>
             <a:r>
-              <a:rPr lang="en-US" sz="3000" b="1" dirty="0">
+              <a:rPr lang="en-US" sz="2600" b="1" dirty="0">
                 <a:solidFill>
                   <a:schemeClr val="bg1"/>
                 </a:solidFill>
               </a:rPr>
-              <a:t>$75,0 M</a:t>
+              <a:t>$75.012.054</a:t>
             </a:r>
-            <a:endParaRPr lang="en-US" sz="3000" dirty="0"/>
+            <a:endParaRPr lang="en-US" sz="2600" dirty="0"/>
           </a:p>
         </p:txBody>
       </p:sp>
@@ -6884,14 +6884,14 @@
               <a:buNone/>
             </a:pPr>
             <a:r>
-              <a:rPr lang="en-US" sz="3000" b="1" dirty="0">
+              <a:rPr lang="en-US" sz="2600" b="1" dirty="0">
                 <a:solidFill>
                   <a:schemeClr val="accent1"/>
                 </a:solidFill>
               </a:rPr>
-              <a:t>$68,6 M</a:t>
+              <a:t>$68.648.289</a:t>
             </a:r>
-            <a:endParaRPr lang="en-US" sz="3000" dirty="0"/>
+            <a:endParaRPr lang="en-US" sz="2600" dirty="0"/>
           </a:p>
         </p:txBody>
       </p:sp>
@@ -7008,14 +7008,14 @@
               <a:buNone/>
             </a:pPr>
             <a:r>
-              <a:rPr lang="en-US" sz="3000" b="1" dirty="0">
+              <a:rPr lang="en-US" sz="2600" b="1" dirty="0">
                 <a:solidFill>
                   <a:schemeClr val="accent6"/>
                 </a:solidFill>
               </a:rPr>
-              <a:t>$0,0 M</a:t>
+              <a:t>$0</a:t>
             </a:r>
-            <a:endParaRPr lang="en-US" sz="3000" dirty="0"/>
+            <a:endParaRPr lang="en-US" sz="2600" dirty="0"/>
           </a:p>
         </p:txBody>
       </p:sp>
@@ -7132,14 +7132,14 @@
               <a:buNone/>
             </a:pPr>
             <a:r>
-              <a:rPr lang="en-US" sz="3000" b="1" dirty="0">
+              <a:rPr lang="en-US" sz="2600" b="1" dirty="0">
                 <a:solidFill>
                   <a:schemeClr val="bg1"/>
                 </a:solidFill>
               </a:rPr>
-              <a:t>$68,6 M</a:t>
+              <a:t>$68.648.289</a:t>
             </a:r>
-            <a:endParaRPr lang="en-US" sz="3000" dirty="0"/>
+            <a:endParaRPr lang="en-US" sz="2600" dirty="0"/>
           </a:p>
         </p:txBody>
       </p:sp>
@@ -7215,7 +7215,7 @@
         <p:spPr>
           <a:xfrm>
             <a:off x="2377440" y="4690872"/>
-            <a:ext cx="2331720" cy="457200"/>
+            <a:ext cx="2377440" cy="457200"/>
           </a:xfrm>
           <a:prstGeom prst="rect">
             <a:avLst/>
@@ -7231,14 +7231,14 @@
               <a:buNone/>
             </a:pPr>
             <a:r>
-              <a:rPr lang="en-US" sz="2600" b="1" dirty="0">
+              <a:rPr lang="en-US" sz="2200" b="1" dirty="0">
                 <a:solidFill>
                   <a:schemeClr val="accent6"/>
                 </a:solidFill>
               </a:rPr>
-              <a:t>▼ −$22,8 M</a:t>
+              <a:t>▼ −$22.761.765</a:t>
             </a:r>
-            <a:endParaRPr lang="en-US" sz="2600" dirty="0"/>
+            <a:endParaRPr lang="en-US" sz="2200" dirty="0"/>
           </a:p>
         </p:txBody>
       </p:sp>
@@ -7350,7 +7350,7 @@
         <p:spPr>
           <a:xfrm>
             <a:off x="5715000" y="4690872"/>
-            <a:ext cx="2331720" cy="457200"/>
+            <a:ext cx="2377440" cy="457200"/>
           </a:xfrm>
           <a:prstGeom prst="rect">
             <a:avLst/>
@@ -7366,14 +7366,14 @@
               <a:buNone/>
             </a:pPr>
             <a:r>
-              <a:rPr lang="en-US" sz="2600" b="1" dirty="0">
+              <a:rPr lang="en-US" sz="2200" b="1" dirty="0">
                 <a:solidFill>
                   <a:schemeClr val="accent2"/>
                 </a:solidFill>
               </a:rPr>
-              <a:t>▼ −$16,4 M</a:t>
+              <a:t>▼ −$16.398.000</a:t>
             </a:r>
-            <a:endParaRPr lang="en-US" sz="2600" dirty="0"/>
+            <a:endParaRPr lang="en-US" sz="2200" dirty="0"/>
           </a:p>
         </p:txBody>
       </p:sp>
@@ -7485,7 +7485,7 @@
         <p:spPr>
           <a:xfrm>
             <a:off x="9052560" y="4690872"/>
-            <a:ext cx="2441448" cy="457200"/>
+            <a:ext cx="2487168" cy="457200"/>
           </a:xfrm>
           <a:prstGeom prst="rect">
             <a:avLst/>
@@ -7501,14 +7501,14 @@
               <a:buNone/>
             </a:pPr>
             <a:r>
-              <a:rPr lang="en-US" sz="2600" b="1" dirty="0">
+              <a:rPr lang="en-US" sz="2200" b="1" dirty="0">
                 <a:solidFill>
                   <a:schemeClr val="accent6"/>
                 </a:solidFill>
               </a:rPr>
-              <a:t>▼ −$6,4 M</a:t>
+              <a:t>▼ −$6.363.765</a:t>
             </a:r>
-            <a:endParaRPr lang="en-US" sz="2600" dirty="0"/>
+            <a:endParaRPr lang="en-US" sz="2200" dirty="0"/>
           </a:p>
         </p:txBody>
       </p:sp>
@@ -7614,7 +7614,7 @@
                   <a:srgbClr val="5A6572"/>
                 </a:solidFill>
               </a:rPr>
-              <a:t>En agosto no hubo devoluciones (julio: $16,4 M, el mayor nivel del año), lo que amortiguó la caída del ingreso bruto. Actividades de consultoría · cifras en millones de pesos.</a:t>
+              <a:t>En agosto no hubo devoluciones (julio: $16.398.000, el mayor nivel del año), lo que amortiguó la caída del ingreso bruto. Actividades de consultoría · cifras en pesos colombianos.</a:t>
             </a:r>
             <a:endParaRPr lang="en-US" sz="1200" dirty="0"/>
           </a:p>
@@ -7818,7 +7818,7 @@
         </p:nvGraphicFramePr>
         <p:xfrm>
           <a:off x="548640" y="1325880"/>
-          <a:ext cx="6400800" cy="4800600"/>
+          <a:ext cx="5852160" cy="4800600"/>
         </p:xfrm>
         <a:graphic xmlns:a="http://schemas.openxmlformats.org/drawingml/2006/main">
           <a:graphicData uri="http://schemas.openxmlformats.org/drawingml/2006/chart">
@@ -7841,8 +7841,8 @@
           </p:nvPr>
         </p:nvGraphicFramePr>
         <p:xfrm>
-          <a:off x="7178040" y="1371600"/>
-          <a:ext cx="4453128" cy="914400"/>
+          <a:off x="6583680" y="1371600"/>
+          <a:ext cx="5047488" cy="914400"/>
         </p:xfrm>
         <a:graphic>
           <a:graphicData uri="http://schemas.openxmlformats.org/drawingml/2006/table">
@@ -7850,8 +7850,8 @@
               <a:tblPr/>
               <a:tblGrid>
                 <a:gridCol w="2011680"/>
-                <a:gridCol w="777240"/>
-                <a:gridCol w="777240"/>
+                <a:gridCol w="1097280"/>
+                <a:gridCol w="1051560"/>
                 <a:gridCol w="886968"/>
               </a:tblGrid>
               <a:tr h="347472">
@@ -8171,14 +8171,14 @@
                         <a:buNone/>
                       </a:pPr>
                       <a:r>
-                        <a:rPr lang="en-US" sz="1200" b="1" dirty="0">
+                        <a:rPr lang="en-US" sz="1100" b="1" dirty="0">
                           <a:solidFill>
                             <a:schemeClr val="accent1"/>
                           </a:solidFill>
                         </a:rPr>
-                        <a:t>16,8</a:t>
+                        <a:t>16.769.915</a:t>
                       </a:r>
-                      <a:endParaRPr lang="en-US" sz="1200" dirty="0"/>
+                      <a:endParaRPr lang="en-US" sz="1100" dirty="0"/>
                     </a:p>
                   </a:txBody>
                   <a:tcPr marL="73152" marR="73152" marT="0" marB="0" anchor="ctr">
@@ -8232,14 +8232,14 @@
                         <a:buNone/>
                       </a:pPr>
                       <a:r>
-                        <a:rPr lang="en-US" sz="1200" dirty="0">
+                        <a:rPr lang="en-US" sz="1100" dirty="0">
                           <a:solidFill>
                             <a:srgbClr val="5A6572"/>
                           </a:solidFill>
                         </a:rPr>
-                        <a:t>13,3</a:t>
+                        <a:t>13.261.581</a:t>
                       </a:r>
-                      <a:endParaRPr lang="en-US" sz="1200" dirty="0"/>
+                      <a:endParaRPr lang="en-US" sz="1100" dirty="0"/>
                     </a:p>
                   </a:txBody>
                   <a:tcPr marL="73152" marR="73152" marT="0" marB="0" anchor="ctr">
@@ -8417,14 +8417,14 @@
                         <a:buNone/>
                       </a:pPr>
                       <a:r>
-                        <a:rPr lang="en-US" sz="1200" b="1" dirty="0">
+                        <a:rPr lang="en-US" sz="1100" b="1" dirty="0">
                           <a:solidFill>
                             <a:schemeClr val="accent1"/>
                           </a:solidFill>
                         </a:rPr>
-                        <a:t>5,8</a:t>
+                        <a:t>5.834.065</a:t>
                       </a:r>
-                      <a:endParaRPr lang="en-US" sz="1200" dirty="0"/>
+                      <a:endParaRPr lang="en-US" sz="1100" dirty="0"/>
                     </a:p>
                   </a:txBody>
                   <a:tcPr marL="73152" marR="73152" marT="0" marB="0" anchor="ctr">
@@ -8478,14 +8478,14 @@
                         <a:buNone/>
                       </a:pPr>
                       <a:r>
-                        <a:rPr lang="en-US" sz="1200" dirty="0">
+                        <a:rPr lang="en-US" sz="1100" dirty="0">
                           <a:solidFill>
                             <a:srgbClr val="5A6572"/>
                           </a:solidFill>
                         </a:rPr>
-                        <a:t>8,5</a:t>
+                        <a:t>8.491.308</a:t>
                       </a:r>
-                      <a:endParaRPr lang="en-US" sz="1200" dirty="0"/>
+                      <a:endParaRPr lang="en-US" sz="1100" dirty="0"/>
                     </a:p>
                   </a:txBody>
                   <a:tcPr marL="73152" marR="73152" marT="0" marB="0" anchor="ctr">
@@ -8663,14 +8663,14 @@
                         <a:buNone/>
                       </a:pPr>
                       <a:r>
-                        <a:rPr lang="en-US" sz="1200" b="1" dirty="0">
+                        <a:rPr lang="en-US" sz="1100" b="1" dirty="0">
                           <a:solidFill>
                             <a:schemeClr val="accent1"/>
                           </a:solidFill>
                         </a:rPr>
-                        <a:t>3,3</a:t>
+                        <a:t>3.306.279</a:t>
                       </a:r>
-                      <a:endParaRPr lang="en-US" sz="1200" dirty="0"/>
+                      <a:endParaRPr lang="en-US" sz="1100" dirty="0"/>
                     </a:p>
                   </a:txBody>
                   <a:tcPr marL="73152" marR="73152" marT="0" marB="0" anchor="ctr">
@@ -8724,14 +8724,14 @@
                         <a:buNone/>
                       </a:pPr>
                       <a:r>
-                        <a:rPr lang="en-US" sz="1200" dirty="0">
+                        <a:rPr lang="en-US" sz="1100" dirty="0">
                           <a:solidFill>
                             <a:srgbClr val="5A6572"/>
                           </a:solidFill>
                         </a:rPr>
-                        <a:t>3,3</a:t>
+                        <a:t>3.306.279</a:t>
                       </a:r>
-                      <a:endParaRPr lang="en-US" sz="1200" dirty="0"/>
+                      <a:endParaRPr lang="en-US" sz="1100" dirty="0"/>
                     </a:p>
                   </a:txBody>
                   <a:tcPr marL="73152" marR="73152" marT="0" marB="0" anchor="ctr">
@@ -8909,14 +8909,14 @@
                         <a:buNone/>
                       </a:pPr>
                       <a:r>
-                        <a:rPr lang="en-US" sz="1200" b="1" dirty="0">
+                        <a:rPr lang="en-US" sz="1100" b="1" dirty="0">
                           <a:solidFill>
                             <a:schemeClr val="accent1"/>
                           </a:solidFill>
                         </a:rPr>
-                        <a:t>2,6</a:t>
+                        <a:t>2.566.854</a:t>
                       </a:r>
-                      <a:endParaRPr lang="en-US" sz="1200" dirty="0"/>
+                      <a:endParaRPr lang="en-US" sz="1100" dirty="0"/>
                     </a:p>
                   </a:txBody>
                   <a:tcPr marL="73152" marR="73152" marT="0" marB="0" anchor="ctr">
@@ -8970,14 +8970,14 @@
                         <a:buNone/>
                       </a:pPr>
                       <a:r>
-                        <a:rPr lang="en-US" sz="1200" dirty="0">
+                        <a:rPr lang="en-US" sz="1100" dirty="0">
                           <a:solidFill>
                             <a:srgbClr val="5A6572"/>
                           </a:solidFill>
                         </a:rPr>
-                        <a:t>2,6</a:t>
+                        <a:t>2.636.966</a:t>
                       </a:r>
-                      <a:endParaRPr lang="en-US" sz="1200" dirty="0"/>
+                      <a:endParaRPr lang="en-US" sz="1100" dirty="0"/>
                     </a:p>
                   </a:txBody>
                   <a:tcPr marL="73152" marR="73152" marT="0" marB="0" anchor="ctr">
@@ -9155,14 +9155,14 @@
                         <a:buNone/>
                       </a:pPr>
                       <a:r>
-                        <a:rPr lang="en-US" sz="1200" b="1" dirty="0">
+                        <a:rPr lang="en-US" sz="1100" b="1" dirty="0">
                           <a:solidFill>
                             <a:schemeClr val="accent1"/>
                           </a:solidFill>
                         </a:rPr>
-                        <a:t>2,5</a:t>
+                        <a:t>2.457.524</a:t>
                       </a:r>
-                      <a:endParaRPr lang="en-US" sz="1200" dirty="0"/>
+                      <a:endParaRPr lang="en-US" sz="1100" dirty="0"/>
                     </a:p>
                   </a:txBody>
                   <a:tcPr marL="73152" marR="73152" marT="0" marB="0" anchor="ctr">
@@ -9216,14 +9216,14 @@
                         <a:buNone/>
                       </a:pPr>
                       <a:r>
-                        <a:rPr lang="en-US" sz="1200" dirty="0">
+                        <a:rPr lang="en-US" sz="1100" dirty="0">
                           <a:solidFill>
                             <a:srgbClr val="5A6572"/>
                           </a:solidFill>
                         </a:rPr>
-                        <a:t>0,6</a:t>
+                        <a:t>636.761</a:t>
                       </a:r>
-                      <a:endParaRPr lang="en-US" sz="1200" dirty="0"/>
+                      <a:endParaRPr lang="en-US" sz="1100" dirty="0"/>
                     </a:p>
                   </a:txBody>
                   <a:tcPr marL="73152" marR="73152" marT="0" marB="0" anchor="ctr">
@@ -9401,14 +9401,14 @@
                         <a:buNone/>
                       </a:pPr>
                       <a:r>
-                        <a:rPr lang="en-US" sz="1200" b="1" dirty="0">
+                        <a:rPr lang="en-US" sz="1100" b="1" dirty="0">
                           <a:solidFill>
                             <a:schemeClr val="accent1"/>
                           </a:solidFill>
                         </a:rPr>
-                        <a:t>2,2</a:t>
+                        <a:t>2.234.749</a:t>
                       </a:r>
-                      <a:endParaRPr lang="en-US" sz="1200" dirty="0"/>
+                      <a:endParaRPr lang="en-US" sz="1100" dirty="0"/>
                     </a:p>
                   </a:txBody>
                   <a:tcPr marL="73152" marR="73152" marT="0" marB="0" anchor="ctr">
@@ -9462,14 +9462,14 @@
                         <a:buNone/>
                       </a:pPr>
                       <a:r>
-                        <a:rPr lang="en-US" sz="1200" dirty="0">
+                        <a:rPr lang="en-US" sz="1100" dirty="0">
                           <a:solidFill>
                             <a:srgbClr val="5A6572"/>
                           </a:solidFill>
                         </a:rPr>
-                        <a:t>2,2</a:t>
+                        <a:t>2.234.749</a:t>
                       </a:r>
-                      <a:endParaRPr lang="en-US" sz="1200" dirty="0"/>
+                      <a:endParaRPr lang="en-US" sz="1100" dirty="0"/>
                     </a:p>
                   </a:txBody>
                   <a:tcPr marL="73152" marR="73152" marT="0" marB="0" anchor="ctr">
@@ -9647,14 +9647,14 @@
                         <a:buNone/>
                       </a:pPr>
                       <a:r>
-                        <a:rPr lang="en-US" sz="1200" b="1" dirty="0">
+                        <a:rPr lang="en-US" sz="1100" b="1" dirty="0">
                           <a:solidFill>
                             <a:schemeClr val="accent1"/>
                           </a:solidFill>
                         </a:rPr>
-                        <a:t>40,8</a:t>
+                        <a:t>40.769.091</a:t>
                       </a:r>
-                      <a:endParaRPr lang="en-US" sz="1200" dirty="0"/>
+                      <a:endParaRPr lang="en-US" sz="1100" dirty="0"/>
                     </a:p>
                   </a:txBody>
                   <a:tcPr marL="73152" marR="73152" marT="0" marB="0" anchor="ctr">
@@ -9708,14 +9708,14 @@
                         <a:buNone/>
                       </a:pPr>
                       <a:r>
-                        <a:rPr lang="en-US" sz="1200" dirty="0">
+                        <a:rPr lang="en-US" sz="1100" dirty="0">
                           <a:solidFill>
                             <a:srgbClr val="5A6572"/>
                           </a:solidFill>
                         </a:rPr>
-                        <a:t>37,7</a:t>
+                        <a:t>37.671.013</a:t>
                       </a:r>
-                      <a:endParaRPr lang="en-US" sz="1200" dirty="0"/>
+                      <a:endParaRPr lang="en-US" sz="1100" dirty="0"/>
                     </a:p>
                   </a:txBody>
                   <a:tcPr marL="73152" marR="73152" marT="0" marB="0" anchor="ctr">
@@ -9834,8 +9834,8 @@
         </p:nvSpPr>
         <p:spPr>
           <a:xfrm>
-            <a:off x="7178040" y="4343400"/>
-            <a:ext cx="4453128" cy="1463040"/>
+            <a:off x="6583680" y="4343400"/>
+            <a:ext cx="5047488" cy="1463040"/>
           </a:xfrm>
           <a:prstGeom prst="roundRect">
             <a:avLst>
@@ -9861,8 +9861,8 @@
         </p:nvSpPr>
         <p:spPr>
           <a:xfrm>
-            <a:off x="7406640" y="4498848"/>
-            <a:ext cx="4023360" cy="347472"/>
+            <a:off x="6812280" y="4498848"/>
+            <a:ext cx="4617720" cy="347472"/>
           </a:xfrm>
           <a:prstGeom prst="rect">
             <a:avLst/>
@@ -9897,8 +9897,8 @@
         </p:nvSpPr>
         <p:spPr>
           <a:xfrm>
-            <a:off x="7406640" y="4919472"/>
-            <a:ext cx="4023360" cy="822960"/>
+            <a:off x="6812280" y="4901184"/>
+            <a:ext cx="4617720" cy="822960"/>
           </a:xfrm>
           <a:prstGeom prst="rect">
             <a:avLst/>
@@ -9914,18 +9914,18 @@
               <a:buNone/>
             </a:pPr>
             <a:r>
-              <a:rPr lang="en-US" sz="1300" dirty="0">
+              <a:rPr lang="en-US" sz="1200" dirty="0">
                 <a:solidFill>
                   <a:schemeClr val="tx1"/>
                 </a:solidFill>
               </a:rPr>
-              <a:t>Los gastos de la Unión Temporal ($16,8 M) son el </a:t>
+              <a:t>Los gastos de la Unión Temporal ($16.769.915) son el </a:t>
             </a:r>
             <a:pPr indent="0" marL="0">
               <a:buNone/>
             </a:pPr>
             <a:r>
-              <a:rPr lang="en-US" sz="1300" b="1" dirty="0">
+              <a:rPr lang="en-US" sz="1200" b="1" dirty="0">
                 <a:solidFill>
                   <a:schemeClr val="accent1"/>
                 </a:solidFill>
@@ -9936,14 +9936,14 @@
               <a:buNone/>
             </a:pPr>
             <a:r>
-              <a:rPr lang="en-US" sz="1300" dirty="0">
+              <a:rPr lang="en-US" sz="1200" dirty="0">
                 <a:solidFill>
                   <a:schemeClr val="tx1"/>
                 </a:solidFill>
               </a:rPr>
-              <a:t> y subieron $3,5 M, más que el aumento total ($3,1 M); los gastos de personal bajaron $2,7 M.</a:t>
+              <a:t> y subieron $3.508.334, más que el aumento total ($3.098.078); los gastos de personal bajaron $2.657.243.</a:t>
             </a:r>
-            <a:endParaRPr lang="en-US" sz="1300" dirty="0"/>
+            <a:endParaRPr lang="en-US" sz="1200" dirty="0"/>
           </a:p>
         </p:txBody>
       </p:sp>
@@ -9955,8 +9955,8 @@
         </p:nvSpPr>
         <p:spPr>
           <a:xfrm>
-            <a:off x="7178040" y="5897880"/>
-            <a:ext cx="4453128" cy="228600"/>
+            <a:off x="6583680" y="5897880"/>
+            <a:ext cx="5047488" cy="228600"/>
           </a:xfrm>
           <a:prstGeom prst="rect">
             <a:avLst/>
@@ -10465,14 +10465,14 @@
               <a:buNone/>
             </a:pPr>
             <a:r>
-              <a:rPr lang="en-US" sz="2000" b="1" dirty="0">
+              <a:rPr lang="en-US" sz="1500" b="1" dirty="0">
                 <a:solidFill>
                   <a:schemeClr val="accent1"/>
                 </a:solidFill>
               </a:rPr>
-              <a:t>$22,9 M</a:t>
+              <a:t>$22.869.000</a:t>
             </a:r>
-            <a:endParaRPr lang="en-US" sz="2000" dirty="0"/>
+            <a:endParaRPr lang="en-US" sz="1500" dirty="0"/>
           </a:p>
         </p:txBody>
       </p:sp>
@@ -10484,8 +10484,8 @@
         </p:nvSpPr>
         <p:spPr>
           <a:xfrm>
-            <a:off x="777240" y="3337560"/>
-            <a:ext cx="3108960" cy="1554480"/>
+            <a:off x="777240" y="3291840"/>
+            <a:ext cx="3108960" cy="1600200"/>
           </a:xfrm>
           <a:prstGeom prst="rect">
             <a:avLst/>
@@ -10501,14 +10501,14 @@
               <a:buNone/>
             </a:pPr>
             <a:r>
-              <a:rPr lang="en-US" sz="1400" dirty="0">
+              <a:rPr lang="en-US" sz="1300" dirty="0">
                 <a:solidFill>
                   <a:schemeClr val="tx1"/>
                 </a:solidFill>
               </a:rPr>
               <a:t>El SIMPLE se paga cada dos meses (febrero, abril, junio, agosto). Julio no tuvo pago; agosto absorbió el bimestre completo y explica la mayor parte de la caída.</a:t>
             </a:r>
-            <a:endParaRPr lang="en-US" sz="1400" dirty="0"/>
+            <a:endParaRPr lang="en-US" sz="1300" dirty="0"/>
           </a:p>
         </p:txBody>
       </p:sp>
@@ -10611,7 +10611,7 @@
                   <a:schemeClr val="accent1"/>
                 </a:solidFill>
               </a:rPr>
-              <a:t>MENORES INGRESOS DE CONSULTORÍA</a:t>
+              <a:t>MENORES INGRESOS BRUTOS DE CONSULTORÍA</a:t>
             </a:r>
             <a:endParaRPr lang="en-US" sz="1400" dirty="0"/>
           </a:p>
@@ -10705,14 +10705,14 @@
               <a:buNone/>
             </a:pPr>
             <a:r>
-              <a:rPr lang="en-US" sz="2000" b="1" dirty="0">
+              <a:rPr lang="en-US" sz="1500" b="1" dirty="0">
                 <a:solidFill>
                   <a:srgbClr val="5A6572"/>
                 </a:solidFill>
               </a:rPr>
-              <a:t>$91,4 M</a:t>
+              <a:t>$91.410.054</a:t>
             </a:r>
-            <a:endParaRPr lang="en-US" sz="2000" dirty="0"/>
+            <a:endParaRPr lang="en-US" sz="1500" dirty="0"/>
           </a:p>
         </p:txBody>
       </p:sp>
@@ -10804,14 +10804,14 @@
               <a:buNone/>
             </a:pPr>
             <a:r>
-              <a:rPr lang="en-US" sz="2000" b="1" dirty="0">
+              <a:rPr lang="en-US" sz="1500" b="1" dirty="0">
                 <a:solidFill>
                   <a:schemeClr val="accent1"/>
                 </a:solidFill>
               </a:rPr>
-              <a:t>$68,6 M</a:t>
+              <a:t>$68.648.289</a:t>
             </a:r>
-            <a:endParaRPr lang="en-US" sz="2000" dirty="0"/>
+            <a:endParaRPr lang="en-US" sz="1500" dirty="0"/>
           </a:p>
         </p:txBody>
       </p:sp>
@@ -10823,8 +10823,8 @@
         </p:nvSpPr>
         <p:spPr>
           <a:xfrm>
-            <a:off x="4539996" y="3337560"/>
-            <a:ext cx="3108960" cy="1554480"/>
+            <a:off x="4539996" y="3291840"/>
+            <a:ext cx="3108960" cy="1600200"/>
           </a:xfrm>
           <a:prstGeom prst="rect">
             <a:avLst/>
@@ -10840,14 +10840,14 @@
               <a:buNone/>
             </a:pPr>
             <a:r>
-              <a:rPr lang="en-US" sz="1400" dirty="0">
+              <a:rPr lang="en-US" sz="1300" dirty="0">
                 <a:solidFill>
                   <a:schemeClr val="tx1"/>
                 </a:solidFill>
               </a:rPr>
               <a:t>Los ingresos brutos cayeron 24,9%. Sin devoluciones en agosto, el ingreso neto bajó solo 8,5%, pero el margen bruto pasó de 71,5% a 66,0%.</a:t>
             </a:r>
-            <a:endParaRPr lang="en-US" sz="1400" dirty="0"/>
+            <a:endParaRPr lang="en-US" sz="1300" dirty="0"/>
           </a:p>
         </p:txBody>
       </p:sp>
@@ -10950,7 +10950,7 @@
                   <a:schemeClr val="accent1"/>
                 </a:solidFill>
               </a:rPr>
-              <a:t>UNIÓN TEMPORAL EVB ABOGADOS</a:t>
+              <a:t>UNIÓN TEMPORAL EVB ABOGADOS · EFECTO NETO</a:t>
             </a:r>
             <a:endParaRPr lang="en-US" sz="1400" dirty="0"/>
           </a:p>
@@ -11044,14 +11044,14 @@
               <a:buNone/>
             </a:pPr>
             <a:r>
-              <a:rPr lang="en-US" sz="1600" b="1" dirty="0">
+              <a:rPr lang="en-US" sz="1500" b="1" dirty="0">
                 <a:solidFill>
                   <a:srgbClr val="5A6572"/>
                 </a:solidFill>
               </a:rPr>
-              <a:t>−$1,4 M neto</a:t>
+              <a:t>−$1.363.844</a:t>
             </a:r>
-            <a:endParaRPr lang="en-US" sz="1600" dirty="0"/>
+            <a:endParaRPr lang="en-US" sz="1500" dirty="0"/>
           </a:p>
         </p:txBody>
       </p:sp>
@@ -11143,14 +11143,14 @@
               <a:buNone/>
             </a:pPr>
             <a:r>
-              <a:rPr lang="en-US" sz="1600" b="1" dirty="0">
+              <a:rPr lang="en-US" sz="1500" b="1" dirty="0">
                 <a:solidFill>
                   <a:schemeClr val="accent1"/>
                 </a:solidFill>
               </a:rPr>
-              <a:t>+$8,2 M neto</a:t>
+              <a:t>+$8.210.902</a:t>
             </a:r>
-            <a:endParaRPr lang="en-US" sz="1600" dirty="0"/>
+            <a:endParaRPr lang="en-US" sz="1500" dirty="0"/>
           </a:p>
         </p:txBody>
       </p:sp>
@@ -11162,8 +11162,8 @@
         </p:nvSpPr>
         <p:spPr>
           <a:xfrm>
-            <a:off x="8302752" y="3337560"/>
-            <a:ext cx="3108960" cy="1554480"/>
+            <a:off x="8302752" y="3291840"/>
+            <a:ext cx="3108960" cy="1600200"/>
           </a:xfrm>
           <a:prstGeom prst="rect">
             <a:avLst/>
@@ -11179,14 +11179,14 @@
               <a:buNone/>
             </a:pPr>
             <a:r>
-              <a:rPr lang="en-US" sz="1400" dirty="0">
+              <a:rPr lang="en-US" sz="1300" dirty="0">
                 <a:solidFill>
                   <a:schemeClr val="tx1"/>
                 </a:solidFill>
               </a:rPr>
-              <a:t>En agosto la UT aportó $35,5 M de ingreso no operacional frente a $27,3 M de gastos asociados ($16,8 M administrativos y $10,5 M no operacionales).</a:t>
+              <a:t>En agosto la UT aportó $35.524.015 de ingreso no operacional frente a $27.313.113 de gastos asociados ($16.769.915 administrativos y $10.543.198 no operacionales).</a:t>
             </a:r>
-            <a:endParaRPr lang="en-US" sz="1400" dirty="0"/>
+            <a:endParaRPr lang="en-US" sz="1300" dirty="0"/>
           </a:p>
         </p:txBody>
       </p:sp>
@@ -11258,7 +11258,7 @@
                   <a:schemeClr val="bg1"/>
                 </a:solidFill>
               </a:rPr>
-              <a:t>antes de impuestos agosto ganó más que julio (+6,8%). La caída de la utilidad neta la explica el SIMPLE; el punto a vigilar es la operación: ingresos brutos −24,9% y resultado operacional de solo $4,5 M.</a:t>
+              <a:t>antes de impuestos agosto ganó más que julio (+6,8%). La caída de la utilidad neta la explica el SIMPLE; el punto a vigilar es la operación: ingresos brutos −24,9% y resultado operacional de solo $4.548.272.</a:t>
             </a:r>
             <a:endParaRPr lang="en-US" sz="1500" dirty="0"/>
           </a:p>
@@ -11699,11 +11699,11 @@
             <a:tbl>
               <a:tblPr/>
               <a:tblGrid>
-                <a:gridCol w="2606040"/>
-                <a:gridCol w="1051560"/>
-                <a:gridCol w="1051560"/>
-                <a:gridCol w="1005840"/>
-                <a:gridCol w="1097280"/>
+                <a:gridCol w="2148840"/>
+                <a:gridCol w="1280160"/>
+                <a:gridCol w="1280160"/>
+                <a:gridCol w="1188720"/>
+                <a:gridCol w="914400"/>
               </a:tblGrid>
               <a:tr h="338328">
                 <a:tc>
@@ -12158,14 +12158,14 @@
                         <a:buNone/>
                       </a:pPr>
                       <a:r>
-                        <a:rPr lang="en-US" sz="1200" b="1" dirty="0">
+                        <a:rPr lang="en-US" sz="1100" b="1" dirty="0">
                           <a:solidFill>
                             <a:schemeClr val="accent1"/>
                           </a:solidFill>
                         </a:rPr>
-                        <a:t>1.075,0</a:t>
+                        <a:t>1.075.010.530</a:t>
                       </a:r>
-                      <a:endParaRPr lang="en-US" sz="1200" dirty="0"/>
+                      <a:endParaRPr lang="en-US" sz="1100" dirty="0"/>
                     </a:p>
                   </a:txBody>
                   <a:tcPr marL="73152" marR="73152" marT="0" marB="0" anchor="ctr">
@@ -12219,14 +12219,14 @@
                         <a:buNone/>
                       </a:pPr>
                       <a:r>
-                        <a:rPr lang="en-US" sz="1200" dirty="0">
+                        <a:rPr lang="en-US" sz="1100" dirty="0">
                           <a:solidFill>
                             <a:srgbClr val="5A6572"/>
                           </a:solidFill>
                         </a:rPr>
-                        <a:t>1.040,6</a:t>
+                        <a:t>1.040.644.254</a:t>
                       </a:r>
-                      <a:endParaRPr lang="en-US" sz="1200" dirty="0"/>
+                      <a:endParaRPr lang="en-US" sz="1100" dirty="0"/>
                     </a:p>
                   </a:txBody>
                   <a:tcPr marL="73152" marR="73152" marT="0" marB="0" anchor="ctr">
@@ -12280,14 +12280,14 @@
                         <a:buNone/>
                       </a:pPr>
                       <a:r>
-                        <a:rPr lang="en-US" sz="1200" b="1" dirty="0">
+                        <a:rPr lang="en-US" sz="1100" b="1" dirty="0">
                           <a:solidFill>
                             <a:schemeClr val="accent2"/>
                           </a:solidFill>
                         </a:rPr>
-                        <a:t>+34,4</a:t>
+                        <a:t>+34.366.276</a:t>
                       </a:r>
-                      <a:endParaRPr lang="en-US" sz="1200" dirty="0"/>
+                      <a:endParaRPr lang="en-US" sz="1100" dirty="0"/>
                     </a:p>
                   </a:txBody>
                   <a:tcPr marL="73152" marR="73152" marT="0" marB="0" anchor="ctr">
@@ -12341,14 +12341,14 @@
                         <a:buNone/>
                       </a:pPr>
                       <a:r>
-                        <a:rPr lang="en-US" sz="1200" b="1" dirty="0">
+                        <a:rPr lang="en-US" sz="1100" b="1" dirty="0">
                           <a:solidFill>
                             <a:schemeClr val="accent2"/>
                           </a:solidFill>
                         </a:rPr>
                         <a:t>+3,3%</a:t>
                       </a:r>
-                      <a:endParaRPr lang="en-US" sz="1200" dirty="0"/>
+                      <a:endParaRPr lang="en-US" sz="1100" dirty="0"/>
                     </a:p>
                   </a:txBody>
                   <a:tcPr marL="73152" marR="73152" marT="0" marB="0" anchor="ctr">
@@ -12465,14 +12465,14 @@
                         <a:buNone/>
                       </a:pPr>
                       <a:r>
-                        <a:rPr lang="en-US" sz="1200" b="1" dirty="0">
+                        <a:rPr lang="en-US" sz="1100" b="1" dirty="0">
                           <a:solidFill>
                             <a:schemeClr val="accent1"/>
                           </a:solidFill>
                         </a:rPr>
-                        <a:t>939,1</a:t>
+                        <a:t>939.078.918</a:t>
                       </a:r>
-                      <a:endParaRPr lang="en-US" sz="1200" dirty="0"/>
+                      <a:endParaRPr lang="en-US" sz="1100" dirty="0"/>
                     </a:p>
                   </a:txBody>
                   <a:tcPr marL="73152" marR="73152" marT="0" marB="0" anchor="ctr">
@@ -12526,14 +12526,14 @@
                         <a:buNone/>
                       </a:pPr>
                       <a:r>
-                        <a:rPr lang="en-US" sz="1200" dirty="0">
+                        <a:rPr lang="en-US" sz="1100" dirty="0">
                           <a:solidFill>
                             <a:srgbClr val="5A6572"/>
                           </a:solidFill>
                         </a:rPr>
-                        <a:t>932,5</a:t>
+                        <a:t>932.524.991</a:t>
                       </a:r>
-                      <a:endParaRPr lang="en-US" sz="1200" dirty="0"/>
+                      <a:endParaRPr lang="en-US" sz="1100" dirty="0"/>
                     </a:p>
                   </a:txBody>
                   <a:tcPr marL="73152" marR="73152" marT="0" marB="0" anchor="ctr">
@@ -12587,14 +12587,14 @@
                         <a:buNone/>
                       </a:pPr>
                       <a:r>
-                        <a:rPr lang="en-US" sz="1200" b="1" dirty="0">
+                        <a:rPr lang="en-US" sz="1100" b="1" dirty="0">
                           <a:solidFill>
                             <a:schemeClr val="accent2"/>
                           </a:solidFill>
                         </a:rPr>
-                        <a:t>+6,6</a:t>
+                        <a:t>+6.553.927</a:t>
                       </a:r>
-                      <a:endParaRPr lang="en-US" sz="1200" dirty="0"/>
+                      <a:endParaRPr lang="en-US" sz="1100" dirty="0"/>
                     </a:p>
                   </a:txBody>
                   <a:tcPr marL="73152" marR="73152" marT="0" marB="0" anchor="ctr">
@@ -12648,14 +12648,14 @@
                         <a:buNone/>
                       </a:pPr>
                       <a:r>
-                        <a:rPr lang="en-US" sz="1200" b="1" dirty="0">
+                        <a:rPr lang="en-US" sz="1100" b="1" dirty="0">
                           <a:solidFill>
                             <a:schemeClr val="accent2"/>
                           </a:solidFill>
                         </a:rPr>
                         <a:t>+0,7%</a:t>
                       </a:r>
-                      <a:endParaRPr lang="en-US" sz="1200" dirty="0"/>
+                      <a:endParaRPr lang="en-US" sz="1100" dirty="0"/>
                     </a:p>
                   </a:txBody>
                   <a:tcPr marL="73152" marR="73152" marT="0" marB="0" anchor="ctr">
@@ -12772,14 +12772,14 @@
                         <a:buNone/>
                       </a:pPr>
                       <a:r>
-                        <a:rPr lang="en-US" sz="1200" b="1" dirty="0">
+                        <a:rPr lang="en-US" sz="1100" b="1" dirty="0">
                           <a:solidFill>
                             <a:schemeClr val="accent1"/>
                           </a:solidFill>
                         </a:rPr>
-                        <a:t>2.014,1</a:t>
+                        <a:t>2.014.089.448</a:t>
                       </a:r>
-                      <a:endParaRPr lang="en-US" sz="1200" dirty="0"/>
+                      <a:endParaRPr lang="en-US" sz="1100" dirty="0"/>
                     </a:p>
                   </a:txBody>
                   <a:tcPr marL="73152" marR="73152" marT="0" marB="0" anchor="ctr">
@@ -12833,14 +12833,14 @@
                         <a:buNone/>
                       </a:pPr>
                       <a:r>
-                        <a:rPr lang="en-US" sz="1200" dirty="0">
+                        <a:rPr lang="en-US" sz="1100" dirty="0">
                           <a:solidFill>
                             <a:srgbClr val="5A6572"/>
                           </a:solidFill>
                         </a:rPr>
-                        <a:t>1.973,2</a:t>
+                        <a:t>1.973.169.245</a:t>
                       </a:r>
-                      <a:endParaRPr lang="en-US" sz="1200" dirty="0"/>
+                      <a:endParaRPr lang="en-US" sz="1100" dirty="0"/>
                     </a:p>
                   </a:txBody>
                   <a:tcPr marL="73152" marR="73152" marT="0" marB="0" anchor="ctr">
@@ -12894,14 +12894,14 @@
                         <a:buNone/>
                       </a:pPr>
                       <a:r>
-                        <a:rPr lang="en-US" sz="1200" b="1" dirty="0">
+                        <a:rPr lang="en-US" sz="1100" b="1" dirty="0">
                           <a:solidFill>
                             <a:schemeClr val="accent2"/>
                           </a:solidFill>
                         </a:rPr>
-                        <a:t>+40,9</a:t>
+                        <a:t>+40.920.203</a:t>
                       </a:r>
-                      <a:endParaRPr lang="en-US" sz="1200" dirty="0"/>
+                      <a:endParaRPr lang="en-US" sz="1100" dirty="0"/>
                     </a:p>
                   </a:txBody>
                   <a:tcPr marL="73152" marR="73152" marT="0" marB="0" anchor="ctr">
@@ -12955,14 +12955,14 @@
                         <a:buNone/>
                       </a:pPr>
                       <a:r>
-                        <a:rPr lang="en-US" sz="1200" b="1" dirty="0">
+                        <a:rPr lang="en-US" sz="1100" b="1" dirty="0">
                           <a:solidFill>
                             <a:schemeClr val="accent2"/>
                           </a:solidFill>
                         </a:rPr>
                         <a:t>+2,1%</a:t>
                       </a:r>
-                      <a:endParaRPr lang="en-US" sz="1200" dirty="0"/>
+                      <a:endParaRPr lang="en-US" sz="1100" dirty="0"/>
                     </a:p>
                   </a:txBody>
                   <a:tcPr marL="73152" marR="73152" marT="0" marB="0" anchor="ctr">
@@ -13154,14 +13154,14 @@
                         <a:buNone/>
                       </a:pPr>
                       <a:r>
-                        <a:rPr lang="en-US" sz="1200" b="1" dirty="0">
+                        <a:rPr lang="en-US" sz="1100" b="1" dirty="0">
                           <a:solidFill>
                             <a:schemeClr val="accent1"/>
                           </a:solidFill>
                         </a:rPr>
-                        <a:t>188,9</a:t>
+                        <a:t>188.850.155</a:t>
                       </a:r>
-                      <a:endParaRPr lang="en-US" sz="1200" dirty="0"/>
+                      <a:endParaRPr lang="en-US" sz="1100" dirty="0"/>
                     </a:p>
                   </a:txBody>
                   <a:tcPr marL="73152" marR="73152" marT="0" marB="0" anchor="ctr">
@@ -13215,14 +13215,14 @@
                         <a:buNone/>
                       </a:pPr>
                       <a:r>
-                        <a:rPr lang="en-US" sz="1200" dirty="0">
+                        <a:rPr lang="en-US" sz="1100" dirty="0">
                           <a:solidFill>
                             <a:srgbClr val="5A6572"/>
                           </a:solidFill>
                         </a:rPr>
-                        <a:t>154,8</a:t>
+                        <a:t>154.834.332</a:t>
                       </a:r>
-                      <a:endParaRPr lang="en-US" sz="1200" dirty="0"/>
+                      <a:endParaRPr lang="en-US" sz="1100" dirty="0"/>
                     </a:p>
                   </a:txBody>
                   <a:tcPr marL="73152" marR="73152" marT="0" marB="0" anchor="ctr">
@@ -13276,14 +13276,14 @@
                         <a:buNone/>
                       </a:pPr>
                       <a:r>
-                        <a:rPr lang="en-US" sz="1200" b="1" dirty="0">
+                        <a:rPr lang="en-US" sz="1100" b="1" dirty="0">
                           <a:solidFill>
                             <a:schemeClr val="accent6"/>
                           </a:solidFill>
                         </a:rPr>
-                        <a:t>+34,0</a:t>
+                        <a:t>+34.015.823</a:t>
                       </a:r>
-                      <a:endParaRPr lang="en-US" sz="1200" dirty="0"/>
+                      <a:endParaRPr lang="en-US" sz="1100" dirty="0"/>
                     </a:p>
                   </a:txBody>
                   <a:tcPr marL="73152" marR="73152" marT="0" marB="0" anchor="ctr">
@@ -13337,14 +13337,14 @@
                         <a:buNone/>
                       </a:pPr>
                       <a:r>
-                        <a:rPr lang="en-US" sz="1200" b="1" dirty="0">
+                        <a:rPr lang="en-US" sz="1100" b="1" dirty="0">
                           <a:solidFill>
                             <a:schemeClr val="accent6"/>
                           </a:solidFill>
                         </a:rPr>
                         <a:t>+22,0%</a:t>
                       </a:r>
-                      <a:endParaRPr lang="en-US" sz="1200" dirty="0"/>
+                      <a:endParaRPr lang="en-US" sz="1100" dirty="0"/>
                     </a:p>
                   </a:txBody>
                   <a:tcPr marL="73152" marR="73152" marT="0" marB="0" anchor="ctr">
@@ -13461,14 +13461,14 @@
                         <a:buNone/>
                       </a:pPr>
                       <a:r>
-                        <a:rPr lang="en-US" sz="1200" b="1" dirty="0">
+                        <a:rPr lang="en-US" sz="1100" b="1" dirty="0">
                           <a:solidFill>
                             <a:schemeClr val="accent1"/>
                           </a:solidFill>
                         </a:rPr>
-                        <a:t>6,0</a:t>
+                        <a:t>5.985.894</a:t>
                       </a:r>
-                      <a:endParaRPr lang="en-US" sz="1200" dirty="0"/>
+                      <a:endParaRPr lang="en-US" sz="1100" dirty="0"/>
                     </a:p>
                   </a:txBody>
                   <a:tcPr marL="73152" marR="73152" marT="0" marB="0" anchor="ctr">
@@ -13522,14 +13522,14 @@
                         <a:buNone/>
                       </a:pPr>
                       <a:r>
-                        <a:rPr lang="en-US" sz="1200" dirty="0">
+                        <a:rPr lang="en-US" sz="1100" dirty="0">
                           <a:solidFill>
                             <a:srgbClr val="5A6572"/>
                           </a:solidFill>
                         </a:rPr>
-                        <a:t>5,3</a:t>
+                        <a:t>5.268.348</a:t>
                       </a:r>
-                      <a:endParaRPr lang="en-US" sz="1200" dirty="0"/>
+                      <a:endParaRPr lang="en-US" sz="1100" dirty="0"/>
                     </a:p>
                   </a:txBody>
                   <a:tcPr marL="73152" marR="73152" marT="0" marB="0" anchor="ctr">
@@ -13583,14 +13583,14 @@
                         <a:buNone/>
                       </a:pPr>
                       <a:r>
-                        <a:rPr lang="en-US" sz="1200" b="1" dirty="0">
+                        <a:rPr lang="en-US" sz="1100" b="1" dirty="0">
                           <a:solidFill>
                             <a:schemeClr val="accent6"/>
                           </a:solidFill>
                         </a:rPr>
-                        <a:t>+0,7</a:t>
+                        <a:t>+717.546</a:t>
                       </a:r>
-                      <a:endParaRPr lang="en-US" sz="1200" dirty="0"/>
+                      <a:endParaRPr lang="en-US" sz="1100" dirty="0"/>
                     </a:p>
                   </a:txBody>
                   <a:tcPr marL="73152" marR="73152" marT="0" marB="0" anchor="ctr">
@@ -13644,14 +13644,14 @@
                         <a:buNone/>
                       </a:pPr>
                       <a:r>
-                        <a:rPr lang="en-US" sz="1200" b="1" dirty="0">
+                        <a:rPr lang="en-US" sz="1100" b="1" dirty="0">
                           <a:solidFill>
                             <a:schemeClr val="accent6"/>
                           </a:solidFill>
                         </a:rPr>
                         <a:t>+13,6%</a:t>
                       </a:r>
-                      <a:endParaRPr lang="en-US" sz="1200" dirty="0"/>
+                      <a:endParaRPr lang="en-US" sz="1100" dirty="0"/>
                     </a:p>
                   </a:txBody>
                   <a:tcPr marL="73152" marR="73152" marT="0" marB="0" anchor="ctr">
@@ -13768,14 +13768,14 @@
                         <a:buNone/>
                       </a:pPr>
                       <a:r>
-                        <a:rPr lang="en-US" sz="1200" b="1" dirty="0">
+                        <a:rPr lang="en-US" sz="1100" b="1" dirty="0">
                           <a:solidFill>
                             <a:schemeClr val="accent1"/>
                           </a:solidFill>
                         </a:rPr>
-                        <a:t>194,8</a:t>
+                        <a:t>194.836.049</a:t>
                       </a:r>
-                      <a:endParaRPr lang="en-US" sz="1200" dirty="0"/>
+                      <a:endParaRPr lang="en-US" sz="1100" dirty="0"/>
                     </a:p>
                   </a:txBody>
                   <a:tcPr marL="73152" marR="73152" marT="0" marB="0" anchor="ctr">
@@ -13829,14 +13829,14 @@
                         <a:buNone/>
                       </a:pPr>
                       <a:r>
-                        <a:rPr lang="en-US" sz="1200" dirty="0">
+                        <a:rPr lang="en-US" sz="1100" dirty="0">
                           <a:solidFill>
                             <a:srgbClr val="5A6572"/>
                           </a:solidFill>
                         </a:rPr>
-                        <a:t>160,1</a:t>
+                        <a:t>160.102.680</a:t>
                       </a:r>
-                      <a:endParaRPr lang="en-US" sz="1200" dirty="0"/>
+                      <a:endParaRPr lang="en-US" sz="1100" dirty="0"/>
                     </a:p>
                   </a:txBody>
                   <a:tcPr marL="73152" marR="73152" marT="0" marB="0" anchor="ctr">
@@ -13890,14 +13890,14 @@
                         <a:buNone/>
                       </a:pPr>
                       <a:r>
-                        <a:rPr lang="en-US" sz="1200" b="1" dirty="0">
+                        <a:rPr lang="en-US" sz="1100" b="1" dirty="0">
                           <a:solidFill>
                             <a:schemeClr val="accent6"/>
                           </a:solidFill>
                         </a:rPr>
-                        <a:t>+34,7</a:t>
+                        <a:t>+34.733.369</a:t>
                       </a:r>
-                      <a:endParaRPr lang="en-US" sz="1200" dirty="0"/>
+                      <a:endParaRPr lang="en-US" sz="1100" dirty="0"/>
                     </a:p>
                   </a:txBody>
                   <a:tcPr marL="73152" marR="73152" marT="0" marB="0" anchor="ctr">
@@ -13951,14 +13951,14 @@
                         <a:buNone/>
                       </a:pPr>
                       <a:r>
-                        <a:rPr lang="en-US" sz="1200" b="1" dirty="0">
+                        <a:rPr lang="en-US" sz="1100" b="1" dirty="0">
                           <a:solidFill>
                             <a:schemeClr val="accent6"/>
                           </a:solidFill>
                         </a:rPr>
                         <a:t>+21,7%</a:t>
                       </a:r>
-                      <a:endParaRPr lang="en-US" sz="1200" dirty="0"/>
+                      <a:endParaRPr lang="en-US" sz="1100" dirty="0"/>
                     </a:p>
                   </a:txBody>
                   <a:tcPr marL="73152" marR="73152" marT="0" marB="0" anchor="ctr">
@@ -14150,14 +14150,14 @@
                         <a:buNone/>
                       </a:pPr>
                       <a:r>
-                        <a:rPr lang="en-US" sz="1200" b="1" dirty="0">
+                        <a:rPr lang="en-US" sz="1100" b="1" dirty="0">
                           <a:solidFill>
                             <a:schemeClr val="accent1"/>
                           </a:solidFill>
                         </a:rPr>
-                        <a:t>1.819,3</a:t>
+                        <a:t>1.819.253.399</a:t>
                       </a:r>
-                      <a:endParaRPr lang="en-US" sz="1200" dirty="0"/>
+                      <a:endParaRPr lang="en-US" sz="1100" dirty="0"/>
                     </a:p>
                   </a:txBody>
                   <a:tcPr marL="73152" marR="73152" marT="0" marB="0" anchor="ctr">
@@ -14211,14 +14211,14 @@
                         <a:buNone/>
                       </a:pPr>
                       <a:r>
-                        <a:rPr lang="en-US" sz="1200" dirty="0">
+                        <a:rPr lang="en-US" sz="1100" dirty="0">
                           <a:solidFill>
                             <a:srgbClr val="5A6572"/>
                           </a:solidFill>
                         </a:rPr>
-                        <a:t>1.813,1</a:t>
+                        <a:t>1.813.066.565</a:t>
                       </a:r>
-                      <a:endParaRPr lang="en-US" sz="1200" dirty="0"/>
+                      <a:endParaRPr lang="en-US" sz="1100" dirty="0"/>
                     </a:p>
                   </a:txBody>
                   <a:tcPr marL="73152" marR="73152" marT="0" marB="0" anchor="ctr">
@@ -14272,14 +14272,14 @@
                         <a:buNone/>
                       </a:pPr>
                       <a:r>
-                        <a:rPr lang="en-US" sz="1200" b="1" dirty="0">
+                        <a:rPr lang="en-US" sz="1100" b="1" dirty="0">
                           <a:solidFill>
                             <a:schemeClr val="accent2"/>
                           </a:solidFill>
                         </a:rPr>
-                        <a:t>+6,2</a:t>
+                        <a:t>+6.186.834</a:t>
                       </a:r>
-                      <a:endParaRPr lang="en-US" sz="1200" dirty="0"/>
+                      <a:endParaRPr lang="en-US" sz="1100" dirty="0"/>
                     </a:p>
                   </a:txBody>
                   <a:tcPr marL="73152" marR="73152" marT="0" marB="0" anchor="ctr">
@@ -14333,14 +14333,14 @@
                         <a:buNone/>
                       </a:pPr>
                       <a:r>
-                        <a:rPr lang="en-US" sz="1200" b="1" dirty="0">
+                        <a:rPr lang="en-US" sz="1100" b="1" dirty="0">
                           <a:solidFill>
                             <a:schemeClr val="accent2"/>
                           </a:solidFill>
                         </a:rPr>
                         <a:t>+0,3%</a:t>
                       </a:r>
-                      <a:endParaRPr lang="en-US" sz="1200" dirty="0"/>
+                      <a:endParaRPr lang="en-US" sz="1100" dirty="0"/>
                     </a:p>
                   </a:txBody>
                   <a:tcPr marL="73152" marR="73152" marT="0" marB="0" anchor="ctr">
@@ -14457,14 +14457,14 @@
                         <a:buNone/>
                       </a:pPr>
                       <a:r>
-                        <a:rPr lang="en-US" sz="1200" b="1" dirty="0">
+                        <a:rPr lang="en-US" sz="1100" b="1" dirty="0">
                           <a:solidFill>
                             <a:schemeClr val="accent1"/>
                           </a:solidFill>
                         </a:rPr>
-                        <a:t>2.014,1</a:t>
+                        <a:t>2.014.089.448</a:t>
                       </a:r>
-                      <a:endParaRPr lang="en-US" sz="1200" dirty="0"/>
+                      <a:endParaRPr lang="en-US" sz="1100" dirty="0"/>
                     </a:p>
                   </a:txBody>
                   <a:tcPr marL="73152" marR="73152" marT="0" marB="0" anchor="ctr">
@@ -14518,14 +14518,14 @@
                         <a:buNone/>
                       </a:pPr>
                       <a:r>
-                        <a:rPr lang="en-US" sz="1200" dirty="0">
+                        <a:rPr lang="en-US" sz="1100" dirty="0">
                           <a:solidFill>
                             <a:srgbClr val="5A6572"/>
                           </a:solidFill>
                         </a:rPr>
-                        <a:t>1.973,2</a:t>
+                        <a:t>1.973.169.245</a:t>
                       </a:r>
-                      <a:endParaRPr lang="en-US" sz="1200" dirty="0"/>
+                      <a:endParaRPr lang="en-US" sz="1100" dirty="0"/>
                     </a:p>
                   </a:txBody>
                   <a:tcPr marL="73152" marR="73152" marT="0" marB="0" anchor="ctr">
@@ -14579,14 +14579,14 @@
                         <a:buNone/>
                       </a:pPr>
                       <a:r>
-                        <a:rPr lang="en-US" sz="1200" b="1" dirty="0">
+                        <a:rPr lang="en-US" sz="1100" b="1" dirty="0">
                           <a:solidFill>
                             <a:schemeClr val="accent2"/>
                           </a:solidFill>
                         </a:rPr>
-                        <a:t>+40,9</a:t>
+                        <a:t>+40.920.203</a:t>
                       </a:r>
-                      <a:endParaRPr lang="en-US" sz="1200" dirty="0"/>
+                      <a:endParaRPr lang="en-US" sz="1100" dirty="0"/>
                     </a:p>
                   </a:txBody>
                   <a:tcPr marL="73152" marR="73152" marT="0" marB="0" anchor="ctr">
@@ -14640,14 +14640,14 @@
                         <a:buNone/>
                       </a:pPr>
                       <a:r>
-                        <a:rPr lang="en-US" sz="1200" b="1" dirty="0">
+                        <a:rPr lang="en-US" sz="1100" b="1" dirty="0">
                           <a:solidFill>
                             <a:schemeClr val="accent2"/>
                           </a:solidFill>
                         </a:rPr>
                         <a:t>+2,1%</a:t>
                       </a:r>
-                      <a:endParaRPr lang="en-US" sz="1200" dirty="0"/>
+                      <a:endParaRPr lang="en-US" sz="1100" dirty="0"/>
                     </a:p>
                   </a:txBody>
                   <a:tcPr marL="73152" marR="73152" marT="0" marB="0" anchor="ctr">
@@ -14754,7 +14754,7 @@
                   <a:schemeClr val="tx1"/>
                 </a:solidFill>
               </a:rPr>
-              <a:t>El activo corriente creció $34,4 M, impulsado por bancos (+$43,9 M); el pasivo corriente subió $34,0 M por el anticipo del SIMPLE por pagar ($44,6 M).</a:t>
+              <a:t>El activo corriente creció $34.366.276, impulsado por bancos (+$43.872.497); el pasivo corriente subió $34.015.823 por el anticipo del SIMPLE por pagar ($44.639.000).</a:t>
             </a:r>
             <a:endParaRPr lang="en-US" sz="1200" dirty="0"/>
           </a:p>
@@ -17256,7 +17256,7 @@
                   <a:schemeClr val="tx1"/>
                 </a:solidFill>
               </a:rPr>
-              <a:t>ROE acumulado: utilidad del año ($197,3 M) sobre el patrimonio.</a:t>
+              <a:t>ROE acumulado: utilidad del año ($197.347.425) sobre el patrimonio.</a:t>
             </a:r>
             <a:endParaRPr lang="en-US" sz="1200" dirty="0"/>
           </a:p>
@@ -17562,7 +17562,7 @@
                   <a:schemeClr val="tx1"/>
                 </a:solidFill>
               </a:rPr>
-              <a:t>($68,6 M vs $75,0 M en julio): los ingresos brutos cayeron 24,9%, compensados en parte porque no hubo devoluciones. El acumulado del año suma $619,0 M.</a:t>
+              <a:t>($68.648.289 vs $75.012.054 en julio): los ingresos brutos cayeron 24,9%, compensados en parte porque no hubo devoluciones. El acumulado del año suma $618.969.676.</a:t>
             </a:r>
             <a:endParaRPr lang="en-US" sz="1400" dirty="0"/>
           </a:p>
@@ -17667,7 +17667,7 @@
                   <a:schemeClr val="accent1"/>
                 </a:solidFill>
               </a:rPr>
-              <a:t>Utilidad neta −77,3% ($6,2 M): </a:t>
+              <a:t>Utilidad neta −77,3% ($6.186.833): </a:t>
             </a:r>
             <a:pPr indent="0" marL="0">
               <a:buNone/>
@@ -17678,7 +17678,7 @@
                   <a:schemeClr val="tx1"/>
                 </a:solidFill>
               </a:rPr>
-              <a:t>la explica el pago bimestral del SIMPLE ($22,9 M); antes de impuestos agosto ganó $29,1 M, 6,8% más que julio.</a:t>
+              <a:t>la explica el pago bimestral del SIMPLE ($22.869.000); antes de impuestos agosto ganó $29.055.833, 6,8% más que julio.</a:t>
             </a:r>
             <a:endParaRPr lang="en-US" sz="1400" dirty="0"/>
           </a:p>
@@ -17783,7 +17783,7 @@
                   <a:schemeClr val="accent1"/>
                 </a:solidFill>
               </a:rPr>
-              <a:t>Resultado operacional de $4,5 M (margen 6,6%): </a:t>
+              <a:t>Resultado operacional de $4.548.272 (margen 6,6%): </a:t>
             </a:r>
             <a:pPr indent="0" marL="0">
               <a:buNone/>
@@ -17910,7 +17910,7 @@
                   <a:schemeClr val="tx1"/>
                 </a:solidFill>
               </a:rPr>
-              <a:t>razón corriente de 5,69 (vs 6,72) y endeudamiento de 9,7% (vs 8,1%), por el anticipo del SIMPLE por pagar ($44,6 M).</a:t>
+              <a:t>razón corriente de 5,69 (vs 6,72) y endeudamiento de 9,7% (vs 8,1%), por el anticipo del SIMPLE por pagar ($44.639.000).</a:t>
             </a:r>
             <a:endParaRPr lang="en-US" sz="1400" dirty="0"/>
           </a:p>
@@ -18026,7 +18026,7 @@
                   <a:schemeClr val="tx1"/>
                 </a:solidFill>
               </a:rPr>
-              <a:t>caja y bancos suben a $146,9 M (+43%) y la utilidad acumulada del año llega a $197,3 M.</a:t>
+              <a:t>caja y bancos suben a $146.850.434 (+43%) y la utilidad acumulada del año llega a $197.347.425.</a:t>
             </a:r>
             <a:endParaRPr lang="en-US" sz="1400" dirty="0"/>
           </a:p>
@@ -21289,7 +21289,7 @@
                             <a:schemeClr val="accent1"/>
                           </a:solidFill>
                         </a:rPr>
-                        <a:t>68,6</a:t>
+                        <a:t>68.648.289</a:t>
                       </a:r>
                       <a:endParaRPr lang="en-US" sz="1200" dirty="0"/>
                     </a:p>
@@ -21350,7 +21350,7 @@
                             <a:srgbClr val="5A6572"/>
                           </a:solidFill>
                         </a:rPr>
-                        <a:t>75,0</a:t>
+                        <a:t>75.012.054</a:t>
                       </a:r>
                       <a:endParaRPr lang="en-US" sz="1200" dirty="0"/>
                     </a:p>
@@ -21411,7 +21411,7 @@
                             <a:schemeClr val="accent6"/>
                           </a:solidFill>
                         </a:rPr>
-                        <a:t>−6,4</a:t>
+                        <a:t>−6.363.765</a:t>
                       </a:r>
                       <a:endParaRPr lang="en-US" sz="1200" dirty="0"/>
                     </a:p>
@@ -21596,7 +21596,7 @@
                             <a:schemeClr val="accent1"/>
                           </a:solidFill>
                         </a:rPr>
-                        <a:t>45,3</a:t>
+                        <a:t>45.317.363</a:t>
                       </a:r>
                       <a:endParaRPr lang="en-US" sz="1200" dirty="0"/>
                     </a:p>
@@ -21657,7 +21657,7 @@
                             <a:srgbClr val="5A6572"/>
                           </a:solidFill>
                         </a:rPr>
-                        <a:t>53,7</a:t>
+                        <a:t>53.666.351</a:t>
                       </a:r>
                       <a:endParaRPr lang="en-US" sz="1200" dirty="0"/>
                     </a:p>
@@ -21718,7 +21718,7 @@
                             <a:schemeClr val="accent6"/>
                           </a:solidFill>
                         </a:rPr>
-                        <a:t>−8,3</a:t>
+                        <a:t>−8.348.988</a:t>
                       </a:r>
                       <a:endParaRPr lang="en-US" sz="1200" dirty="0"/>
                     </a:p>
@@ -21903,7 +21903,7 @@
                             <a:schemeClr val="accent1"/>
                           </a:solidFill>
                         </a:rPr>
-                        <a:t>40,8</a:t>
+                        <a:t>40.769.091</a:t>
                       </a:r>
                       <a:endParaRPr lang="en-US" sz="1200" dirty="0"/>
                     </a:p>
@@ -21964,7 +21964,7 @@
                             <a:srgbClr val="5A6572"/>
                           </a:solidFill>
                         </a:rPr>
-                        <a:t>37,7</a:t>
+                        <a:t>37.671.013</a:t>
                       </a:r>
                       <a:endParaRPr lang="en-US" sz="1200" dirty="0"/>
                     </a:p>
@@ -22025,7 +22025,7 @@
                             <a:schemeClr val="accent6"/>
                           </a:solidFill>
                         </a:rPr>
-                        <a:t>+3,1</a:t>
+                        <a:t>+3.098.078</a:t>
                       </a:r>
                       <a:endParaRPr lang="en-US" sz="1200" dirty="0"/>
                     </a:p>
@@ -22210,7 +22210,7 @@
                             <a:schemeClr val="accent1"/>
                           </a:solidFill>
                         </a:rPr>
-                        <a:t>4,5</a:t>
+                        <a:t>4.548.272</a:t>
                       </a:r>
                       <a:endParaRPr lang="en-US" sz="1200" dirty="0"/>
                     </a:p>
@@ -22271,7 +22271,7 @@
                             <a:srgbClr val="5A6572"/>
                           </a:solidFill>
                         </a:rPr>
-                        <a:t>16,0</a:t>
+                        <a:t>15.995.338</a:t>
                       </a:r>
                       <a:endParaRPr lang="en-US" sz="1200" dirty="0"/>
                     </a:p>
@@ -22332,7 +22332,7 @@
                             <a:schemeClr val="accent6"/>
                           </a:solidFill>
                         </a:rPr>
-                        <a:t>−11,4</a:t>
+                        <a:t>−11.447.066</a:t>
                       </a:r>
                       <a:endParaRPr lang="en-US" sz="1200" dirty="0"/>
                     </a:p>
@@ -22517,7 +22517,7 @@
                             <a:schemeClr val="accent1"/>
                           </a:solidFill>
                         </a:rPr>
-                        <a:t>29,1</a:t>
+                        <a:t>29.055.833</a:t>
                       </a:r>
                       <a:endParaRPr lang="en-US" sz="1200" dirty="0"/>
                     </a:p>
@@ -22578,7 +22578,7 @@
                             <a:srgbClr val="5A6572"/>
                           </a:solidFill>
                         </a:rPr>
-                        <a:t>27,2</a:t>
+                        <a:t>27.205.730</a:t>
                       </a:r>
                       <a:endParaRPr lang="en-US" sz="1200" dirty="0"/>
                     </a:p>
@@ -22639,7 +22639,7 @@
                             <a:schemeClr val="accent2"/>
                           </a:solidFill>
                         </a:rPr>
-                        <a:t>+1,9</a:t>
+                        <a:t>+1.850.103</a:t>
                       </a:r>
                       <a:endParaRPr lang="en-US" sz="1200" dirty="0"/>
                     </a:p>
@@ -22824,7 +22824,7 @@
                             <a:schemeClr val="accent1"/>
                           </a:solidFill>
                         </a:rPr>
-                        <a:t>6,2</a:t>
+                        <a:t>6.186.833</a:t>
                       </a:r>
                       <a:endParaRPr lang="en-US" sz="1200" dirty="0"/>
                     </a:p>
@@ -22885,7 +22885,7 @@
                             <a:srgbClr val="5A6572"/>
                           </a:solidFill>
                         </a:rPr>
-                        <a:t>27,2</a:t>
+                        <a:t>27.205.730</a:t>
                       </a:r>
                       <a:endParaRPr lang="en-US" sz="1200" dirty="0"/>
                     </a:p>
@@ -22946,7 +22946,7 @@
                             <a:schemeClr val="accent6"/>
                           </a:solidFill>
                         </a:rPr>
-                        <a:t>−21,0</a:t>
+                        <a:t>−21.018.897</a:t>
                       </a:r>
                       <a:endParaRPr lang="en-US" sz="1200" dirty="0"/>
                     </a:p>
@@ -23206,7 +23206,7 @@
                             <a:schemeClr val="accent1"/>
                           </a:solidFill>
                         </a:rPr>
-                        <a:t>2.014,1</a:t>
+                        <a:t>2.014.089.448</a:t>
                       </a:r>
                       <a:endParaRPr lang="en-US" sz="1200" dirty="0"/>
                     </a:p>
@@ -23267,7 +23267,7 @@
                             <a:srgbClr val="5A6572"/>
                           </a:solidFill>
                         </a:rPr>
-                        <a:t>1.973,2</a:t>
+                        <a:t>1.973.169.245</a:t>
                       </a:r>
                       <a:endParaRPr lang="en-US" sz="1200" dirty="0"/>
                     </a:p>
@@ -23328,7 +23328,7 @@
                             <a:schemeClr val="accent2"/>
                           </a:solidFill>
                         </a:rPr>
-                        <a:t>+40,9</a:t>
+                        <a:t>+40.920.203</a:t>
                       </a:r>
                       <a:endParaRPr lang="en-US" sz="1200" dirty="0"/>
                     </a:p>
@@ -23513,7 +23513,7 @@
                             <a:schemeClr val="accent1"/>
                           </a:solidFill>
                         </a:rPr>
-                        <a:t>194,8</a:t>
+                        <a:t>194.836.049</a:t>
                       </a:r>
                       <a:endParaRPr lang="en-US" sz="1200" dirty="0"/>
                     </a:p>
@@ -23574,7 +23574,7 @@
                             <a:srgbClr val="5A6572"/>
                           </a:solidFill>
                         </a:rPr>
-                        <a:t>160,1</a:t>
+                        <a:t>160.102.680</a:t>
                       </a:r>
                       <a:endParaRPr lang="en-US" sz="1200" dirty="0"/>
                     </a:p>
@@ -23635,7 +23635,7 @@
                             <a:schemeClr val="accent6"/>
                           </a:solidFill>
                         </a:rPr>
-                        <a:t>+34,7</a:t>
+                        <a:t>+34.733.369</a:t>
                       </a:r>
                       <a:endParaRPr lang="en-US" sz="1200" dirty="0"/>
                     </a:p>
@@ -23820,7 +23820,7 @@
                             <a:schemeClr val="accent1"/>
                           </a:solidFill>
                         </a:rPr>
-                        <a:t>1.819,3</a:t>
+                        <a:t>1.819.253.399</a:t>
                       </a:r>
                       <a:endParaRPr lang="en-US" sz="1200" dirty="0"/>
                     </a:p>
@@ -23881,7 +23881,7 @@
                             <a:srgbClr val="5A6572"/>
                           </a:solidFill>
                         </a:rPr>
-                        <a:t>1.813,1</a:t>
+                        <a:t>1.813.066.565</a:t>
                       </a:r>
                       <a:endParaRPr lang="en-US" sz="1200" dirty="0"/>
                     </a:p>
@@ -23942,7 +23942,7 @@
                             <a:schemeClr val="accent2"/>
                           </a:solidFill>
                         </a:rPr>
-                        <a:t>+6,2</a:t>
+                        <a:t>+6.186.834</a:t>
                       </a:r>
                       <a:endParaRPr lang="en-US" sz="1200" dirty="0"/>
                     </a:p>
@@ -24085,7 +24085,7 @@
                   <a:srgbClr val="5A6572"/>
                 </a:solidFill>
               </a:rPr>
-              <a:t>Cifras en millones de pesos colombianos.   Código de color:  turquesa = favorable  ·  rojo = desfavorable</a:t>
+              <a:t>Cifras en pesos colombianos.   Código de color:  turquesa = favorable  ·  rojo = desfavorable</a:t>
             </a:r>
             <a:endParaRPr lang="en-US" sz="1100" dirty="0"/>
           </a:p>
@@ -24369,7 +24369,7 @@
         <p:spPr>
           <a:xfrm>
             <a:off x="8549640" y="2011680"/>
-            <a:ext cx="2880360" cy="3931920"/>
+            <a:ext cx="2926080" cy="3931920"/>
           </a:xfrm>
           <a:prstGeom prst="rect">
             <a:avLst/>
@@ -24385,12 +24385,12 @@
               <a:buNone/>
             </a:pPr>
             <a:r>
-              <a:rPr lang="en-US" sz="1300" b="1" dirty="0">
+              <a:rPr lang="en-US" sz="1200" b="1" dirty="0">
                 <a:solidFill>
                   <a:schemeClr val="accent1"/>
                 </a:solidFill>
               </a:rPr>
-              <a:t>Operación: −$8,3 M. </a:t>
+              <a:t>Operación: −$8.348.988. </a:t>
             </a:r>
             <a:pPr indent="0" marL="0">
               <a:spcAft>
@@ -24399,26 +24399,26 @@
               <a:buNone/>
             </a:pPr>
             <a:r>
-              <a:rPr lang="en-US" sz="1300" dirty="0">
+              <a:rPr lang="en-US" sz="1200" dirty="0">
                 <a:solidFill>
                   <a:schemeClr val="tx1"/>
                 </a:solidFill>
               </a:rPr>
-              <a:t>Caen los ingresos netos ($6,4 M) y sube el costo de operación ($2,0 M).</a:t>
+              <a:t>Caen los ingresos netos ($6.363.765) y sube el costo de operación ($1.985.223).</a:t>
             </a:r>
-            <a:endParaRPr lang="en-US" sz="1300" dirty="0"/>
+            <a:endParaRPr lang="en-US" sz="1200" dirty="0"/>
           </a:p>
           <a:p>
             <a:pPr indent="0" marL="0">
               <a:buNone/>
             </a:pPr>
             <a:r>
-              <a:rPr lang="en-US" sz="1300" b="1" dirty="0">
+              <a:rPr lang="en-US" sz="1200" b="1" dirty="0">
                 <a:solidFill>
                   <a:schemeClr val="accent1"/>
                 </a:solidFill>
               </a:rPr>
-              <a:t>Gastos admon.: −$3,1 M. </a:t>
+              <a:t>Gastos admon.: −$3.098.078. </a:t>
             </a:r>
             <a:pPr indent="0" marL="0">
               <a:spcAft>
@@ -24427,26 +24427,26 @@
               <a:buNone/>
             </a:pPr>
             <a:r>
-              <a:rPr lang="en-US" sz="1300" dirty="0">
+              <a:rPr lang="en-US" sz="1200" dirty="0">
                 <a:solidFill>
                   <a:schemeClr val="tx1"/>
                 </a:solidFill>
               </a:rPr>
-              <a:t>Sube la Unión Temporal (+$3,5 M) y bajan los gastos de personal ($2,7 M menos).</a:t>
+              <a:t>Sube la Unión Temporal ($3.508.334) y bajan los gastos de personal ($2.657.243).</a:t>
             </a:r>
-            <a:endParaRPr lang="en-US" sz="1300" dirty="0"/>
+            <a:endParaRPr lang="en-US" sz="1200" dirty="0"/>
           </a:p>
           <a:p>
             <a:pPr indent="0" marL="0">
               <a:buNone/>
             </a:pPr>
             <a:r>
-              <a:rPr lang="en-US" sz="1300" b="1" dirty="0">
+              <a:rPr lang="en-US" sz="1200" b="1" dirty="0">
                 <a:solidFill>
                   <a:schemeClr val="accent1"/>
                 </a:solidFill>
               </a:rPr>
-              <a:t>No operacional: +$13,3 M. </a:t>
+              <a:t>No operacional: +$13.297.168. </a:t>
             </a:r>
             <a:pPr indent="0" marL="0">
               <a:spcAft>
@@ -24455,26 +24455,26 @@
               <a:buNone/>
             </a:pPr>
             <a:r>
-              <a:rPr lang="en-US" sz="1300" dirty="0">
+              <a:rPr lang="en-US" sz="1200" dirty="0">
                 <a:solidFill>
                   <a:schemeClr val="tx1"/>
                 </a:solidFill>
               </a:rPr>
-              <a:t>Suben los ingresos ($3,1 M) y bajan los gastos no operacionales ($10,2 M).</a:t>
+              <a:t>Suben los ingresos ($3.106.500) y bajan los gastos no operacionales ($10.190.668).</a:t>
             </a:r>
-            <a:endParaRPr lang="en-US" sz="1300" dirty="0"/>
+            <a:endParaRPr lang="en-US" sz="1200" dirty="0"/>
           </a:p>
           <a:p>
             <a:pPr indent="0" marL="0">
               <a:buNone/>
             </a:pPr>
             <a:r>
-              <a:rPr lang="en-US" sz="1300" b="1" dirty="0">
+              <a:rPr lang="en-US" sz="1200" b="1" dirty="0">
                 <a:solidFill>
                   <a:schemeClr val="accent1"/>
                 </a:solidFill>
               </a:rPr>
-              <a:t>Impuesto SIMPLE: −$22,9 M. </a:t>
+              <a:t>Impuesto SIMPLE: −$22.869.000. </a:t>
             </a:r>
             <a:pPr indent="0" marL="0">
               <a:spcAft>
@@ -24483,14 +24483,14 @@
               <a:buNone/>
             </a:pPr>
             <a:r>
-              <a:rPr lang="en-US" sz="1300" dirty="0">
+              <a:rPr lang="en-US" sz="1200" dirty="0">
                 <a:solidFill>
                   <a:schemeClr val="tx1"/>
                 </a:solidFill>
               </a:rPr>
               <a:t>Pago bimestral que julio no tuvo.</a:t>
             </a:r>
-            <a:endParaRPr lang="en-US" sz="1300" dirty="0"/>
+            <a:endParaRPr lang="en-US" sz="1200" dirty="0"/>
           </a:p>
         </p:txBody>
       </p:sp>
@@ -24723,10 +24723,10 @@
             <a:tbl>
               <a:tblPr/>
               <a:tblGrid>
-                <a:gridCol w="777240"/>
-                <a:gridCol w="1069848"/>
-                <a:gridCol w="1069848"/>
-                <a:gridCol w="987552"/>
+                <a:gridCol w="640080"/>
+                <a:gridCol w="1161288"/>
+                <a:gridCol w="1161288"/>
+                <a:gridCol w="941832"/>
               </a:tblGrid>
               <a:tr h="292608">
                 <a:tc>
@@ -25045,14 +25045,14 @@
                         <a:buNone/>
                       </a:pPr>
                       <a:r>
-                        <a:rPr lang="en-US" sz="1200" dirty="0">
+                        <a:rPr lang="en-US" sz="1100" dirty="0">
                           <a:solidFill>
                             <a:schemeClr val="tx1"/>
                           </a:solidFill>
                         </a:rPr>
-                        <a:t>63,2</a:t>
+                        <a:t>63.161.460</a:t>
                       </a:r>
-                      <a:endParaRPr lang="en-US" sz="1200" dirty="0"/>
+                      <a:endParaRPr lang="en-US" sz="1100" dirty="0"/>
                     </a:p>
                   </a:txBody>
                   <a:tcPr marL="73152" marR="73152" marT="0" marB="0" anchor="ctr">
@@ -25106,14 +25106,14 @@
                         <a:buNone/>
                       </a:pPr>
                       <a:r>
-                        <a:rPr lang="en-US" sz="1200" dirty="0">
+                        <a:rPr lang="en-US" sz="1100" dirty="0">
                           <a:solidFill>
                             <a:schemeClr val="tx1"/>
                           </a:solidFill>
                         </a:rPr>
-                        <a:t>14,4</a:t>
+                        <a:t>14.367.398</a:t>
                       </a:r>
-                      <a:endParaRPr lang="en-US" sz="1200" dirty="0"/>
+                      <a:endParaRPr lang="en-US" sz="1100" dirty="0"/>
                     </a:p>
                   </a:txBody>
                   <a:tcPr marL="73152" marR="73152" marT="0" marB="0" anchor="ctr">
@@ -25291,14 +25291,14 @@
                         <a:buNone/>
                       </a:pPr>
                       <a:r>
-                        <a:rPr lang="en-US" sz="1200" dirty="0">
+                        <a:rPr lang="en-US" sz="1100" dirty="0">
                           <a:solidFill>
                             <a:schemeClr val="tx1"/>
                           </a:solidFill>
                         </a:rPr>
-                        <a:t>70,9</a:t>
+                        <a:t>70.894.572</a:t>
                       </a:r>
-                      <a:endParaRPr lang="en-US" sz="1200" dirty="0"/>
+                      <a:endParaRPr lang="en-US" sz="1100" dirty="0"/>
                     </a:p>
                   </a:txBody>
                   <a:tcPr marL="73152" marR="73152" marT="0" marB="0" anchor="ctr">
@@ -25352,14 +25352,14 @@
                         <a:buNone/>
                       </a:pPr>
                       <a:r>
-                        <a:rPr lang="en-US" sz="1200" dirty="0">
+                        <a:rPr lang="en-US" sz="1100" dirty="0">
                           <a:solidFill>
                             <a:schemeClr val="tx1"/>
                           </a:solidFill>
                         </a:rPr>
-                        <a:t>1,7</a:t>
+                        <a:t>1.660.746</a:t>
                       </a:r>
-                      <a:endParaRPr lang="en-US" sz="1200" dirty="0"/>
+                      <a:endParaRPr lang="en-US" sz="1100" dirty="0"/>
                     </a:p>
                   </a:txBody>
                   <a:tcPr marL="73152" marR="73152" marT="0" marB="0" anchor="ctr">
@@ -25537,14 +25537,14 @@
                         <a:buNone/>
                       </a:pPr>
                       <a:r>
-                        <a:rPr lang="en-US" sz="1200" dirty="0">
+                        <a:rPr lang="en-US" sz="1100" dirty="0">
                           <a:solidFill>
                             <a:schemeClr val="tx1"/>
                           </a:solidFill>
                         </a:rPr>
-                        <a:t>74,4</a:t>
+                        <a:t>74.422.717</a:t>
                       </a:r>
-                      <a:endParaRPr lang="en-US" sz="1200" dirty="0"/>
+                      <a:endParaRPr lang="en-US" sz="1100" dirty="0"/>
                     </a:p>
                   </a:txBody>
                   <a:tcPr marL="73152" marR="73152" marT="0" marB="0" anchor="ctr">
@@ -25598,14 +25598,14 @@
                         <a:buNone/>
                       </a:pPr>
                       <a:r>
-                        <a:rPr lang="en-US" sz="1200" dirty="0">
+                        <a:rPr lang="en-US" sz="1100" dirty="0">
                           <a:solidFill>
                             <a:schemeClr val="tx1"/>
                           </a:solidFill>
                         </a:rPr>
-                        <a:t>34,4</a:t>
+                        <a:t>34.373.836</a:t>
                       </a:r>
-                      <a:endParaRPr lang="en-US" sz="1200" dirty="0"/>
+                      <a:endParaRPr lang="en-US" sz="1100" dirty="0"/>
                     </a:p>
                   </a:txBody>
                   <a:tcPr marL="73152" marR="73152" marT="0" marB="0" anchor="ctr">
@@ -25783,14 +25783,14 @@
                         <a:buNone/>
                       </a:pPr>
                       <a:r>
-                        <a:rPr lang="en-US" sz="1200" dirty="0">
+                        <a:rPr lang="en-US" sz="1100" dirty="0">
                           <a:solidFill>
                             <a:schemeClr val="tx1"/>
                           </a:solidFill>
                         </a:rPr>
-                        <a:t>73,5</a:t>
+                        <a:t>73.518.795</a:t>
                       </a:r>
-                      <a:endParaRPr lang="en-US" sz="1200" dirty="0"/>
+                      <a:endParaRPr lang="en-US" sz="1100" dirty="0"/>
                     </a:p>
                   </a:txBody>
                   <a:tcPr marL="73152" marR="73152" marT="0" marB="0" anchor="ctr">
@@ -25844,14 +25844,14 @@
                         <a:buNone/>
                       </a:pPr>
                       <a:r>
-                        <a:rPr lang="en-US" sz="1200" dirty="0">
+                        <a:rPr lang="en-US" sz="1100" dirty="0">
                           <a:solidFill>
                             <a:schemeClr val="tx1"/>
                           </a:solidFill>
                         </a:rPr>
-                        <a:t>18,4</a:t>
+                        <a:t>18.444.744</a:t>
                       </a:r>
-                      <a:endParaRPr lang="en-US" sz="1200" dirty="0"/>
+                      <a:endParaRPr lang="en-US" sz="1100" dirty="0"/>
                     </a:p>
                   </a:txBody>
                   <a:tcPr marL="73152" marR="73152" marT="0" marB="0" anchor="ctr">
@@ -26029,14 +26029,14 @@
                         <a:buNone/>
                       </a:pPr>
                       <a:r>
-                        <a:rPr lang="en-US" sz="1200" dirty="0">
+                        <a:rPr lang="en-US" sz="1100" dirty="0">
                           <a:solidFill>
                             <a:schemeClr val="tx1"/>
                           </a:solidFill>
                         </a:rPr>
-                        <a:t>91,1</a:t>
+                        <a:t>91.144.572</a:t>
                       </a:r>
-                      <a:endParaRPr lang="en-US" sz="1200" dirty="0"/>
+                      <a:endParaRPr lang="en-US" sz="1100" dirty="0"/>
                     </a:p>
                   </a:txBody>
                   <a:tcPr marL="73152" marR="73152" marT="0" marB="0" anchor="ctr">
@@ -26090,14 +26090,14 @@
                         <a:buNone/>
                       </a:pPr>
                       <a:r>
-                        <a:rPr lang="en-US" sz="1200" dirty="0">
+                        <a:rPr lang="en-US" sz="1100" dirty="0">
                           <a:solidFill>
                             <a:schemeClr val="tx1"/>
                           </a:solidFill>
                         </a:rPr>
-                        <a:t>70,6</a:t>
+                        <a:t>70.624.102</a:t>
                       </a:r>
-                      <a:endParaRPr lang="en-US" sz="1200" dirty="0"/>
+                      <a:endParaRPr lang="en-US" sz="1100" dirty="0"/>
                     </a:p>
                   </a:txBody>
                   <a:tcPr marL="73152" marR="73152" marT="0" marB="0" anchor="ctr">
@@ -26275,14 +26275,14 @@
                         <a:buNone/>
                       </a:pPr>
                       <a:r>
-                        <a:rPr lang="en-US" sz="1200" dirty="0">
+                        <a:rPr lang="en-US" sz="1100" dirty="0">
                           <a:solidFill>
                             <a:schemeClr val="tx1"/>
                           </a:solidFill>
                         </a:rPr>
-                        <a:t>102,2</a:t>
+                        <a:t>102.167.217</a:t>
                       </a:r>
-                      <a:endParaRPr lang="en-US" sz="1200" dirty="0"/>
+                      <a:endParaRPr lang="en-US" sz="1100" dirty="0"/>
                     </a:p>
                   </a:txBody>
                   <a:tcPr marL="73152" marR="73152" marT="0" marB="0" anchor="ctr">
@@ -26336,14 +26336,14 @@
                         <a:buNone/>
                       </a:pPr>
                       <a:r>
-                        <a:rPr lang="en-US" sz="1200" dirty="0">
+                        <a:rPr lang="en-US" sz="1100" dirty="0">
                           <a:solidFill>
                             <a:schemeClr val="tx1"/>
                           </a:solidFill>
                         </a:rPr>
-                        <a:t>24,5</a:t>
+                        <a:t>24.484.035</a:t>
                       </a:r>
-                      <a:endParaRPr lang="en-US" sz="1200" dirty="0"/>
+                      <a:endParaRPr lang="en-US" sz="1100" dirty="0"/>
                     </a:p>
                   </a:txBody>
                   <a:tcPr marL="73152" marR="73152" marT="0" marB="0" anchor="ctr">
@@ -26521,14 +26521,14 @@
                         <a:buNone/>
                       </a:pPr>
                       <a:r>
-                        <a:rPr lang="en-US" sz="1200" dirty="0">
+                        <a:rPr lang="en-US" sz="1100" dirty="0">
                           <a:solidFill>
                             <a:schemeClr val="tx1"/>
                           </a:solidFill>
                         </a:rPr>
-                        <a:t>75,0</a:t>
+                        <a:t>75.012.054</a:t>
                       </a:r>
-                      <a:endParaRPr lang="en-US" sz="1200" dirty="0"/>
+                      <a:endParaRPr lang="en-US" sz="1100" dirty="0"/>
                     </a:p>
                   </a:txBody>
                   <a:tcPr marL="73152" marR="73152" marT="0" marB="0" anchor="ctr">
@@ -26582,14 +26582,14 @@
                         <a:buNone/>
                       </a:pPr>
                       <a:r>
-                        <a:rPr lang="en-US" sz="1200" dirty="0">
+                        <a:rPr lang="en-US" sz="1100" dirty="0">
                           <a:solidFill>
                             <a:schemeClr val="tx1"/>
                           </a:solidFill>
                         </a:rPr>
-                        <a:t>27,2</a:t>
+                        <a:t>27.205.730</a:t>
                       </a:r>
-                      <a:endParaRPr lang="en-US" sz="1200" dirty="0"/>
+                      <a:endParaRPr lang="en-US" sz="1100" dirty="0"/>
                     </a:p>
                   </a:txBody>
                   <a:tcPr marL="73152" marR="73152" marT="0" marB="0" anchor="ctr">
@@ -26767,14 +26767,14 @@
                         <a:buNone/>
                       </a:pPr>
                       <a:r>
-                        <a:rPr lang="en-US" sz="1200" dirty="0">
+                        <a:rPr lang="en-US" sz="1100" dirty="0">
                           <a:solidFill>
                             <a:schemeClr val="tx1"/>
                           </a:solidFill>
                         </a:rPr>
-                        <a:t>68,6</a:t>
+                        <a:t>68.648.289</a:t>
                       </a:r>
-                      <a:endParaRPr lang="en-US" sz="1200" dirty="0"/>
+                      <a:endParaRPr lang="en-US" sz="1100" dirty="0"/>
                     </a:p>
                   </a:txBody>
                   <a:tcPr marL="73152" marR="73152" marT="0" marB="0" anchor="ctr">
@@ -26828,14 +26828,14 @@
                         <a:buNone/>
                       </a:pPr>
                       <a:r>
-                        <a:rPr lang="en-US" sz="1200" dirty="0">
+                        <a:rPr lang="en-US" sz="1100" dirty="0">
                           <a:solidFill>
                             <a:schemeClr val="tx1"/>
                           </a:solidFill>
                         </a:rPr>
-                        <a:t>6,2</a:t>
+                        <a:t>6.186.833</a:t>
                       </a:r>
-                      <a:endParaRPr lang="en-US" sz="1200" dirty="0"/>
+                      <a:endParaRPr lang="en-US" sz="1100" dirty="0"/>
                     </a:p>
                   </a:txBody>
                   <a:tcPr marL="73152" marR="73152" marT="0" marB="0" anchor="ctr">
@@ -27013,14 +27013,14 @@
                         <a:buNone/>
                       </a:pPr>
                       <a:r>
-                        <a:rPr lang="en-US" sz="1200" b="1" dirty="0">
+                        <a:rPr lang="en-US" sz="1100" b="1" dirty="0">
                           <a:solidFill>
                             <a:schemeClr val="accent1"/>
                           </a:solidFill>
                         </a:rPr>
-                        <a:t>619,0</a:t>
+                        <a:t>618.969.676</a:t>
                       </a:r>
-                      <a:endParaRPr lang="en-US" sz="1200" dirty="0"/>
+                      <a:endParaRPr lang="en-US" sz="1100" dirty="0"/>
                     </a:p>
                   </a:txBody>
                   <a:tcPr marL="73152" marR="73152" marT="0" marB="0" anchor="ctr">
@@ -27074,14 +27074,14 @@
                         <a:buNone/>
                       </a:pPr>
                       <a:r>
-                        <a:rPr lang="en-US" sz="1200" b="1" dirty="0">
+                        <a:rPr lang="en-US" sz="1100" b="1" dirty="0">
                           <a:solidFill>
                             <a:schemeClr val="accent1"/>
                           </a:solidFill>
                         </a:rPr>
-                        <a:t>197,3</a:t>
+                        <a:t>197.347.425</a:t>
                       </a:r>
-                      <a:endParaRPr lang="en-US" sz="1200" dirty="0"/>
+                      <a:endParaRPr lang="en-US" sz="1100" dirty="0"/>
                     </a:p>
                   </a:txBody>
                   <a:tcPr marL="73152" marR="73152" marT="0" marB="0" anchor="ctr">
@@ -27249,7 +27249,7 @@
                   <a:schemeClr val="accent2"/>
                 </a:solidFill>
               </a:rPr>
-              <a:t>$619,0 M</a:t>
+              <a:t>$618.969.676</a:t>
             </a:r>
             <a:endParaRPr lang="en-US" sz="3000" dirty="0"/>
           </a:p>
@@ -27285,7 +27285,7 @@
                   <a:schemeClr val="tx1"/>
                 </a:solidFill>
               </a:rPr>
-              <a:t>Ingresos netos acumulados de enero a agosto. Tras el pico de junio ($102,2 M), los ingresos bajaron en julio (−26,6%) y agosto (−8,5%).</a:t>
+              <a:t>Ingresos netos acumulados de enero a agosto. Tras el pico de junio ($102.167.217), los ingresos bajaron en julio (−26,6%) y agosto (−8,5%).</a:t>
             </a:r>
             <a:endParaRPr lang="en-US" sz="1200" dirty="0"/>
           </a:p>

</xml_diff>